<commit_message>
Polish public portfolio content and archive historical slides
</commit_message>
<xml_diff>
--- a/docs/portfolio/HALY-Operations-Control-Tower-Case-Study-Revised.pptx
+++ b/docs/portfolio/HALY-Operations-Control-Tower-Case-Study-Revised.pptx
@@ -2,26 +2,26 @@
 <file path=ppt/presentation.xml><?xml version="1.0" encoding="utf-8"?>
 <p:presentation xmlns:p="http://schemas.openxmlformats.org/presentationml/2006/main">
   <p:sldMasterIdLst>
-    <p:sldMasterId xmlns:r="http://schemas.openxmlformats.org/officeDocument/2006/relationships" id="2147483648" r:id="R3c2b8fe526f84486"/>
+    <p:sldMasterId xmlns:r="http://schemas.openxmlformats.org/officeDocument/2006/relationships" id="2147483648" r:id="R31f48e639e054b50"/>
   </p:sldMasterIdLst>
   <p:notesMasterIdLst>
-    <p:notesMasterId xmlns:r="http://schemas.openxmlformats.org/officeDocument/2006/relationships" r:id="R24f7e8d93ea44f89"/>
+    <p:notesMasterId xmlns:r="http://schemas.openxmlformats.org/officeDocument/2006/relationships" r:id="R02c492a9e5614272"/>
   </p:notesMasterIdLst>
   <p:sldIdLst>
-    <p:sldId xmlns:r="http://schemas.openxmlformats.org/officeDocument/2006/relationships" id="256" r:id="R2ad74b42574842a1"/>
-    <p:sldId xmlns:r="http://schemas.openxmlformats.org/officeDocument/2006/relationships" id="257" r:id="R9383cade93904fbb"/>
-    <p:sldId xmlns:r="http://schemas.openxmlformats.org/officeDocument/2006/relationships" id="258" r:id="R983311894c27451b"/>
-    <p:sldId xmlns:r="http://schemas.openxmlformats.org/officeDocument/2006/relationships" id="259" r:id="Rcde3bda0fdd04745"/>
-    <p:sldId xmlns:r="http://schemas.openxmlformats.org/officeDocument/2006/relationships" id="260" r:id="Rc593fcc4b7d5444b"/>
-    <p:sldId xmlns:r="http://schemas.openxmlformats.org/officeDocument/2006/relationships" id="261" r:id="R783e8ae5fe4949d6"/>
-    <p:sldId xmlns:r="http://schemas.openxmlformats.org/officeDocument/2006/relationships" id="262" r:id="R54ffca875bf04e4d"/>
-    <p:sldId xmlns:r="http://schemas.openxmlformats.org/officeDocument/2006/relationships" id="263" r:id="R0885809193784b48"/>
-    <p:sldId xmlns:r="http://schemas.openxmlformats.org/officeDocument/2006/relationships" id="264" r:id="Rc39409fa16d9453c"/>
-    <p:sldId xmlns:r="http://schemas.openxmlformats.org/officeDocument/2006/relationships" id="265" r:id="Rccf87d40e019461a"/>
-    <p:sldId xmlns:r="http://schemas.openxmlformats.org/officeDocument/2006/relationships" id="266" r:id="R79ea0d55002b47f7"/>
-    <p:sldId xmlns:r="http://schemas.openxmlformats.org/officeDocument/2006/relationships" id="267" r:id="R4565fbcecdc24c3f"/>
-    <p:sldId xmlns:r="http://schemas.openxmlformats.org/officeDocument/2006/relationships" id="268" r:id="R52a9fa0222544dad"/>
-    <p:sldId xmlns:r="http://schemas.openxmlformats.org/officeDocument/2006/relationships" id="269" r:id="R3d70d4dbe26c4aca"/>
+    <p:sldId xmlns:r="http://schemas.openxmlformats.org/officeDocument/2006/relationships" id="256" r:id="Rec8293195a2d416b"/>
+    <p:sldId xmlns:r="http://schemas.openxmlformats.org/officeDocument/2006/relationships" id="257" r:id="R903902cbf06e4c3a"/>
+    <p:sldId xmlns:r="http://schemas.openxmlformats.org/officeDocument/2006/relationships" id="258" r:id="R167ac55b3bfa4555"/>
+    <p:sldId xmlns:r="http://schemas.openxmlformats.org/officeDocument/2006/relationships" id="259" r:id="R46a70dbf1fff497c"/>
+    <p:sldId xmlns:r="http://schemas.openxmlformats.org/officeDocument/2006/relationships" id="260" r:id="Rc4da5ca905cf4aa8"/>
+    <p:sldId xmlns:r="http://schemas.openxmlformats.org/officeDocument/2006/relationships" id="261" r:id="R7118ff7f8e4f4e64"/>
+    <p:sldId xmlns:r="http://schemas.openxmlformats.org/officeDocument/2006/relationships" id="262" r:id="R0442d3cb8697471c"/>
+    <p:sldId xmlns:r="http://schemas.openxmlformats.org/officeDocument/2006/relationships" id="263" r:id="Rcc7ed5ce103d4f1c"/>
+    <p:sldId xmlns:r="http://schemas.openxmlformats.org/officeDocument/2006/relationships" id="264" r:id="R11f3980727e94467"/>
+    <p:sldId xmlns:r="http://schemas.openxmlformats.org/officeDocument/2006/relationships" id="265" r:id="Rc890480ac9e2464b"/>
+    <p:sldId xmlns:r="http://schemas.openxmlformats.org/officeDocument/2006/relationships" id="266" r:id="R7dca13037d3b44be"/>
+    <p:sldId xmlns:r="http://schemas.openxmlformats.org/officeDocument/2006/relationships" id="267" r:id="R922e2e25b56d44de"/>
+    <p:sldId xmlns:r="http://schemas.openxmlformats.org/officeDocument/2006/relationships" id="268" r:id="Rd072e937362a48ba"/>
+    <p:sldId xmlns:r="http://schemas.openxmlformats.org/officeDocument/2006/relationships" id="269" r:id="R623e0487aeff40d8"/>
   </p:sldIdLst>
   <p:sldSz cx="12192000" cy="6858000"/>
   <p:notesSz cx="6858000" cy="9144000"/>
@@ -455,7 +455,7 @@
           <a:lstStyle xmlns:a="http://schemas.openxmlformats.org/drawingml/2006/main"/>
           <a:p xmlns:a="http://schemas.openxmlformats.org/drawingml/2006/main">
             <a:r>
-              <a:t>HALY is a fictional powdered-drink manufacturer. This portfolio demonstrates a realistic campaign-fulfilment problem with synthetic data. The project connects accepted dispatch promises to stock allocation, controlled shipments and accountable exceptions. It is a local demonstration with source published to a Private GitHub repository, not a production client implementation. The cover is an AI-generated representative concept image, not a photograph of an actual HALY company or facility.</a:t>
+              <a:t>HALY is a fictional powdered-drink manufacturer. This portfolio demonstrates a realistic campaign-fulfilment problem with synthetic data. The project connects accepted dispatch promises to stock allocation, controlled shipments and accountable exceptions. The source repository is on GitHub. This is a local portfolio demonstration with no production client implementation. The cover is an AI-generated representative concept image, not a photograph of an actual HALY company or facility.</a:t>
             </a:r>
           </a:p>
           <a:p xmlns:a="http://schemas.openxmlformats.org/drawingml/2006/main">
@@ -625,7 +625,7 @@
           </a:p>
           <a:p xmlns:a="http://schemas.openxmlformats.org/drawingml/2006/main">
             <a:r>
-              <a:t>Sources: docs/evidence/task-0007/12-final-preparation-guard.png; docs/TASKS.md,TASK-0007 repair history.</a:t>
+              <a:t>Sources: docs/evidence/task-0007/12-final-preparation-guard.png; docs/TASKS.md, TASK-0007 repair history.</a:t>
             </a:r>
           </a:p>
         </p:txBody>
@@ -775,7 +775,7 @@
           <a:lstStyle xmlns:a="http://schemas.openxmlformats.org/drawingml/2006/main"/>
           <a:p xmlns:a="http://schemas.openxmlformats.org/drawingml/2006/main">
             <a:r>
-              <a:t>Yusuf owns the project and approved its business rules. The work includes requirement clarification, standard-flow assessment, focused extensions, synthetic scenarios, negative/concurrency checks and review-driven repairs. AI-assisted implementation supported this work. The recorded local result is 81 methods:8 base, 22 promise, 51 campaign, plus 11 campaign probe cases. These are historical local results, not 81 GitHub CI tests and not business performance KPIs. No time-saving, ROI or delivery-rate improvement has been measured. Date history makes commitments visible, priority controls stock decisions, shipment guards enforce customer policy and a linked risk item assigns follow-up. Supported scope is one-step make-to-stock with configured untracked goods. Staff record customer responses and physical work. Capacity planning, carrier/WMS integration, formal quality release, authenticated consent and production hosting are not delivered. Future options are proposals, not approved commitments.</a:t>
+              <a:t>Yusuf owns the project and approved its business rules. The work includes requirement clarification, standard-flow assessment, focused extensions, synthetic scenarios, negative/concurrency checks and review-driven repairs. AI-assisted implementation and a separate agent review supported this work. Local validation on 15 October 2026 passed 81 test methods with zero failures and zero errors: 8 base, 22 promise and 51 campaign methods. A separate campaign probe passed 11 cases. These historical local results are separate from GitHub CI and business performance KPIs. No time-saving, ROI or delivery-rate improvement has been measured. Date history makes commitments visible, priority controls stock decisions, shipment guards enforce customer policy and a linked risk item assigns follow-up. Supported scope is one-step make-to-stock with configured untracked goods. Staff record customer responses and physical work. Capacity planning, carrier/WMS integration, formal quality release, authenticated consent and production hosting are not delivered. Future options are proposals, not approved commitments.</a:t>
             </a:r>
           </a:p>
           <a:p xmlns:a="http://schemas.openxmlformats.org/drawingml/2006/main">
@@ -785,7 +785,7 @@
           </a:p>
           <a:p xmlns:a="http://schemas.openxmlformats.org/drawingml/2006/main">
             <a:r>
-              <a:t>Sources: docs/TASKS.md,TASK-0003 through TASK-0008; docs/ARCHITECTURE.md; docs/DECISIONS.md; docs/evidence/task-0007/README.md.</a:t>
+              <a:t>Sources: docs/TASKS.md, TASK-0003 through TASK-0010; docs/ARCHITECTURE.md; docs/DECISIONS.md; docs/evidence/task-0007/README.md.</a:t>
             </a:r>
           </a:p>
         </p:txBody>
@@ -855,7 +855,7 @@
           <a:lstStyle xmlns:a="http://schemas.openxmlformats.org/drawingml/2006/main"/>
           <a:p xmlns:a="http://schemas.openxmlformats.org/drawingml/2006/main">
             <a:r>
-              <a:t>Source repository: https://github.com/yusufondes/Operations-Control-Tower . The repository is Private at the verified publication checkpoint, so readers need access. No installation is needed to understand this deck. The source uses Odoo 19 Community, Python, PostgreSQL15, Docker, XML/CSV and PowerShell. Git/GitHub retain both initial histories. Development was AI-assisted with Codex and independent agent review. Local 81/11 checks passed. The first remote CI run passed repository checks and 8 base tests but failed its later HTTP-health check with curl 56; do not claim green CI or full campaign remote coverage. TASK-0008 preview-helper fixes are local/unpushed at this checkpoint. No production deployment or customer messaging exists.</a:t>
+              <a:t>Source repository: https://github.com/yusufondes/Operations-Control-Tower . No installation is needed to understand this deck. The source uses Odoo 19 Community, Python, PostgreSQL 15, Docker, XML/CSV and PowerShell. Git and GitHub preserve the project history. Development was AI-assisted with Codex and a separate agent review. Local validation on 15 October 2026 passed 81 custom-addon test methods and 11 separate campaign probe cases. GitHub CI covers repository checks and the eight base-addon test methods. The optional promise and campaign suites use a separate local validation runner. This deck does not claim full campaign coverage in remote CI. The repository README and Actions page provide current build status. No production deployment or automated customer messaging exists.</a:t>
             </a:r>
           </a:p>
           <a:p xmlns:a="http://schemas.openxmlformats.org/drawingml/2006/main">
@@ -865,7 +865,7 @@
           </a:p>
           <a:p xmlns:a="http://schemas.openxmlformats.org/drawingml/2006/main">
             <a:r>
-              <a:t>Sources: README.md; compose.yaml; .github/workflows/ci.yml; docs/TASKS.md,TASK-0006,TASK-0008. Repository: https://github.com/yusufondes/Operations-Control-Tower . CI evidence: https://github.com/yusufondes/Operations-Control-Tower/actions/runs/38748554245 .</a:t>
+              <a:t>Sources: README.md; compose.yaml; .github/workflows/ci.yml; docs/TASKS.md, TASK-0010 and TASK-0012. Repository: https://github.com/yusufondes/Operations-Control-Tower . Actions: https://github.com/yusufondes/Operations-Control-Tower/actions .</a:t>
             </a:r>
           </a:p>
         </p:txBody>
@@ -1015,7 +1015,7 @@
           <a:lstStyle xmlns:a="http://schemas.openxmlformats.org/drawingml/2006/main"/>
           <a:p xmlns:a="http://schemas.openxmlformats.org/drawingml/2006/main">
             <a:r>
-              <a:t>This is the business workflow, not a claim that physical work happens automatically. Sales establishes the accepted warehouse dispatch commitment. The campaign addon allocates eligible stock under the approved policy. Procurement and manufacturing users record real input receipts and completed production. Warehouse users prepare and validate shipments. Derived risk information supports coordinated follow-up.</a:t>
+              <a:t>This is the business workflow. Physical work does not happen automatically. Sales establishes the accepted warehouse dispatch commitment. The campaign addon allocates eligible stock under the approved policy. Procurement and manufacturing users record input receipts and completed production. Warehouse users prepare and validate shipments. All operations in this demonstration use synthetic records. Derived risk information supports coordinated follow-up.</a:t>
             </a:r>
           </a:p>
           <a:p xmlns:a="http://schemas.openxmlformats.org/drawingml/2006/main">
@@ -1095,7 +1095,7 @@
           <a:lstStyle xmlns:a="http://schemas.openxmlformats.org/drawingml/2006/main"/>
           <a:p xmlns:a="http://schemas.openxmlformats.org/drawingml/2006/main">
             <a:r>
-              <a:t>Initial allocation is A200, B300, C0. The first accepted dispatch date receives stock first. For equal dates, earlier confirmation wins. Stable order ID breaks an exact tie. An incomplete individual order retains its eligible allocated stock but cannot ship until complete. These are illustrative warehouse-dispatch dates, not delivery dates or a promised universal service level. Arithmetic: 200+600+100=900 ordered and 200+300+0=500 initially allocated.</a:t>
+              <a:t>Initial allocation is A 200, B 300, C 0. The first accepted dispatch date receives stock first. For equal dates, earlier confirmation wins. Stable order ID breaks an exact tie. An incomplete individual order retains its eligible allocated stock but cannot ship until complete. These are illustrative warehouse-dispatch dates, not delivery dates or a promised universal service level. Arithmetic: 200+600+100=900 ordered and 200+300+0=500 initially allocated.</a:t>
             </a:r>
           </a:p>
           <a:p xmlns:a="http://schemas.openxmlformats.org/drawingml/2006/main">
@@ -1105,7 +1105,7 @@
           </a:p>
           <a:p xmlns:a="http://schemas.openxmlformats.org/drawingml/2006/main">
             <a:r>
-              <a:t>Sources: docs/DEMO.md, Campaign walkthrough table; docs/DECISIONS.md,D-015; Repository: docs/DEMO.md; docs/TASKS.md, TASK-0007; docs/evidence/task-0007/README.md.</a:t>
+              <a:t>Sources: docs/DEMO.md, Campaign walkthrough table; docs/DECISIONS.md, D-015; Repository: docs/DEMO.md; docs/TASKS.md, TASK-0007; docs/evidence/task-0007/README.md.</a:t>
             </a:r>
           </a:p>
         </p:txBody>
@@ -1185,7 +1185,7 @@
           </a:p>
           <a:p xmlns:a="http://schemas.openxmlformats.org/drawingml/2006/main">
             <a:r>
-              <a:t>Sources: docs/evidence/task-0007/04-accepted-date-history.png; docs/DECISIONS.md,D-011,D-012,D-015; Repository: docs/DEMO.md; docs/TASKS.md, TASK-0007; docs/evidence/task-0007/README.md.</a:t>
+              <a:t>Sources: docs/evidence/task-0007/04-accepted-date-history.png; docs/DECISIONS.md, D-011, D-012, D-015; Repository: docs/DEMO.md; docs/TASKS.md, TASK-0007; docs/evidence/task-0007/README.md.</a:t>
             </a:r>
           </a:p>
         </p:txBody>
@@ -1552,7 +1552,7 @@
           <p:cNvPr id="3" name="Title">
             <a:extLst xmlns:a="http://schemas.openxmlformats.org/drawingml/2006/main">
               <a:ext uri="{FF2B5EF4-FFF2-40B4-BE49-F238E27FC236}">
-                <a16:creationId xmlns:a16="http://schemas.microsoft.com/office/drawing/2014/main" id="{110D1C68-FCE9-462E-B12F-DF83EAE2EE90}"/>
+                <a16:creationId xmlns:a16="http://schemas.microsoft.com/office/drawing/2014/main" id="{ED26B3F3-ADFF-4B47-8A7B-B59F53B728FB}"/>
               </a:ext>
             </a:extLst>
           </p:cNvPr>
@@ -1709,7 +1709,7 @@
           <p:cNvPr id="2" name="Subtitle">
             <a:extLst xmlns:a="http://schemas.openxmlformats.org/drawingml/2006/main">
               <a:ext uri="{FF2B5EF4-FFF2-40B4-BE49-F238E27FC236}">
-                <a16:creationId xmlns:a16="http://schemas.microsoft.com/office/drawing/2014/main" id="{E4EA46B2-D8B4-48D8-B9D8-B5BF5CBE0E75}"/>
+                <a16:creationId xmlns:a16="http://schemas.microsoft.com/office/drawing/2014/main" id="{65EDEE5D-7E9C-4B36-A28C-C8861F3F20B4}"/>
               </a:ext>
             </a:extLst>
           </p:cNvPr>
@@ -1883,7 +1883,7 @@
           <p:cNvPr id="2" name="Section title">
             <a:extLst xmlns:a="http://schemas.openxmlformats.org/drawingml/2006/main">
               <a:ext uri="{FF2B5EF4-FFF2-40B4-BE49-F238E27FC236}">
-                <a16:creationId xmlns:a16="http://schemas.microsoft.com/office/drawing/2014/main" id="{F23A0039-148B-4303-9779-50617C341751}"/>
+                <a16:creationId xmlns:a16="http://schemas.microsoft.com/office/drawing/2014/main" id="{1D69D710-0C2F-4456-864A-EDA1588D1F1D}"/>
               </a:ext>
             </a:extLst>
           </p:cNvPr>
@@ -2057,7 +2057,7 @@
           <p:cNvPr id="3" name="Title">
             <a:extLst xmlns:a="http://schemas.openxmlformats.org/drawingml/2006/main">
               <a:ext uri="{FF2B5EF4-FFF2-40B4-BE49-F238E27FC236}">
-                <a16:creationId xmlns:a16="http://schemas.microsoft.com/office/drawing/2014/main" id="{C917282A-04DC-4F08-9155-199A447C6A54}"/>
+                <a16:creationId xmlns:a16="http://schemas.microsoft.com/office/drawing/2014/main" id="{A3E47B7B-65CA-41FE-A13C-89E68788C068}"/>
               </a:ext>
             </a:extLst>
           </p:cNvPr>
@@ -2214,7 +2214,7 @@
           <p:cNvPr id="2" name="Body">
             <a:extLst xmlns:a="http://schemas.openxmlformats.org/drawingml/2006/main">
               <a:ext uri="{FF2B5EF4-FFF2-40B4-BE49-F238E27FC236}">
-                <a16:creationId xmlns:a16="http://schemas.microsoft.com/office/drawing/2014/main" id="{4905692A-91A4-47C9-984B-2BA0731CB316}"/>
+                <a16:creationId xmlns:a16="http://schemas.microsoft.com/office/drawing/2014/main" id="{DB3B6325-7825-45E8-A5E8-8068195EB6CE}"/>
               </a:ext>
             </a:extLst>
           </p:cNvPr>
@@ -2388,7 +2388,7 @@
           <p:cNvPr id="4" name="Title">
             <a:extLst xmlns:a="http://schemas.openxmlformats.org/drawingml/2006/main">
               <a:ext uri="{FF2B5EF4-FFF2-40B4-BE49-F238E27FC236}">
-                <a16:creationId xmlns:a16="http://schemas.microsoft.com/office/drawing/2014/main" id="{D24996BD-014E-4521-AE8D-B85CA1BAF86D}"/>
+                <a16:creationId xmlns:a16="http://schemas.microsoft.com/office/drawing/2014/main" id="{7E6F8D51-9A9D-401A-A83F-21F8C2F699DB}"/>
               </a:ext>
             </a:extLst>
           </p:cNvPr>
@@ -2545,7 +2545,7 @@
           <p:cNvPr id="2" name="Left column">
             <a:extLst xmlns:a="http://schemas.openxmlformats.org/drawingml/2006/main">
               <a:ext uri="{FF2B5EF4-FFF2-40B4-BE49-F238E27FC236}">
-                <a16:creationId xmlns:a16="http://schemas.microsoft.com/office/drawing/2014/main" id="{77A844EA-FA22-4D14-80A3-9DCDDD533E3F}"/>
+                <a16:creationId xmlns:a16="http://schemas.microsoft.com/office/drawing/2014/main" id="{46F53219-4877-4642-9817-9B5D6756405E}"/>
               </a:ext>
             </a:extLst>
           </p:cNvPr>
@@ -2702,7 +2702,7 @@
           <p:cNvPr id="3" name="Right column">
             <a:extLst xmlns:a="http://schemas.openxmlformats.org/drawingml/2006/main">
               <a:ext uri="{FF2B5EF4-FFF2-40B4-BE49-F238E27FC236}">
-                <a16:creationId xmlns:a16="http://schemas.microsoft.com/office/drawing/2014/main" id="{800E5317-DDDB-4509-B6A9-3F9DBCE28AF0}"/>
+                <a16:creationId xmlns:a16="http://schemas.microsoft.com/office/drawing/2014/main" id="{B0ADE9DA-C04F-46C8-BB0E-9BE7C674D9D8}"/>
               </a:ext>
             </a:extLst>
           </p:cNvPr>
@@ -2876,7 +2876,7 @@
           <p:cNvPr id="3" name="Title">
             <a:extLst xmlns:a="http://schemas.openxmlformats.org/drawingml/2006/main">
               <a:ext uri="{FF2B5EF4-FFF2-40B4-BE49-F238E27FC236}">
-                <a16:creationId xmlns:a16="http://schemas.microsoft.com/office/drawing/2014/main" id="{AD5B1B6A-08E6-498B-B40A-25A68013B6C5}"/>
+                <a16:creationId xmlns:a16="http://schemas.microsoft.com/office/drawing/2014/main" id="{AFD01663-362A-4FC3-9411-8AC8F22284A4}"/>
               </a:ext>
             </a:extLst>
           </p:cNvPr>
@@ -3033,7 +3033,7 @@
           <p:cNvPr id="2" name="Left column">
             <a:extLst xmlns:a="http://schemas.openxmlformats.org/drawingml/2006/main">
               <a:ext uri="{FF2B5EF4-FFF2-40B4-BE49-F238E27FC236}">
-                <a16:creationId xmlns:a16="http://schemas.microsoft.com/office/drawing/2014/main" id="{B18562A3-3F6B-40EF-8F89-759C133FF445}"/>
+                <a16:creationId xmlns:a16="http://schemas.microsoft.com/office/drawing/2014/main" id="{1B8209F2-11D8-418E-A187-65265C002ACD}"/>
               </a:ext>
             </a:extLst>
           </p:cNvPr>
@@ -3228,12 +3228,12 @@
   </p:cSld>
   <p:clrMap bg1="lt1" tx1="dk1" bg2="lt2" tx2="dk2" accent1="accent1" accent2="accent2" accent3="accent3" accent4="accent4" accent5="accent5" accent6="accent6" hlink="hlink" folHlink="folHlink"/>
   <p:sldLayoutIdLst>
-    <p:sldLayoutId xmlns:r="http://schemas.openxmlformats.org/officeDocument/2006/relationships" id="2147483649" r:id="R77c7752380e54d59"/>
-    <p:sldLayoutId xmlns:r="http://schemas.openxmlformats.org/officeDocument/2006/relationships" id="2147483650" r:id="Rb4008c4352ab4abd"/>
-    <p:sldLayoutId xmlns:r="http://schemas.openxmlformats.org/officeDocument/2006/relationships" id="2147483651" r:id="Rc2a0c21c97a94401"/>
-    <p:sldLayoutId xmlns:r="http://schemas.openxmlformats.org/officeDocument/2006/relationships" id="2147483652" r:id="Rf555ac047ad84928"/>
-    <p:sldLayoutId xmlns:r="http://schemas.openxmlformats.org/officeDocument/2006/relationships" id="2147483653" r:id="Rb48929a0e27b4dcb"/>
-    <p:sldLayoutId xmlns:r="http://schemas.openxmlformats.org/officeDocument/2006/relationships" id="2147483654" r:id="R003962e4aa1b46ca"/>
+    <p:sldLayoutId xmlns:r="http://schemas.openxmlformats.org/officeDocument/2006/relationships" id="2147483649" r:id="R1e542b72b0584347"/>
+    <p:sldLayoutId xmlns:r="http://schemas.openxmlformats.org/officeDocument/2006/relationships" id="2147483650" r:id="R4c814271394042ee"/>
+    <p:sldLayoutId xmlns:r="http://schemas.openxmlformats.org/officeDocument/2006/relationships" id="2147483651" r:id="Rc8b302b4045b4e8b"/>
+    <p:sldLayoutId xmlns:r="http://schemas.openxmlformats.org/officeDocument/2006/relationships" id="2147483652" r:id="R8bec7644eaef4796"/>
+    <p:sldLayoutId xmlns:r="http://schemas.openxmlformats.org/officeDocument/2006/relationships" id="2147483653" r:id="R9dc55bc8c52f4a0f"/>
+    <p:sldLayoutId xmlns:r="http://schemas.openxmlformats.org/officeDocument/2006/relationships" id="2147483654" r:id="R2c1cbfc525fb4e9c"/>
   </p:sldLayoutIdLst>
   <p:txStyles>
     <p:titleStyle>
@@ -3781,10 +3781,10 @@
       </p:grpSpPr>
       <p:sp>
         <p:nvSpPr>
-          <p:cNvPr id="8" name="text-se39ke-0">
+          <p:cNvPr id="8" name="text-ensct8-0">
             <a:extLst xmlns:a="http://schemas.openxmlformats.org/drawingml/2006/main">
               <a:ext uri="{FF2B5EF4-FFF2-40B4-BE49-F238E27FC236}">
-                <a16:creationId xmlns:a16="http://schemas.microsoft.com/office/drawing/2014/main" id="{67D0CDF0-FFE8-4DD0-9A2B-3F473BAFB518}"/>
+                <a16:creationId xmlns:a16="http://schemas.microsoft.com/office/drawing/2014/main" id="{D1A6A940-7905-4FB6-98B7-1B321C41AF97}"/>
               </a:ext>
             </a:extLst>
           </p:cNvPr>
@@ -3849,10 +3849,10 @@
       </p:sp>
       <p:sp>
         <p:nvSpPr>
-          <p:cNvPr id="2" name="text-se39ke-1">
+          <p:cNvPr id="2" name="text-ensct8-1">
             <a:extLst xmlns:a="http://schemas.openxmlformats.org/drawingml/2006/main">
               <a:ext uri="{FF2B5EF4-FFF2-40B4-BE49-F238E27FC236}">
-                <a16:creationId xmlns:a16="http://schemas.microsoft.com/office/drawing/2014/main" id="{E9A510B4-D76B-415D-A563-6BD86CE0E4ED}"/>
+                <a16:creationId xmlns:a16="http://schemas.microsoft.com/office/drawing/2014/main" id="{FF851886-2B22-458B-B62E-97CE03AEBD00}"/>
               </a:ext>
             </a:extLst>
           </p:cNvPr>
@@ -3920,7 +3920,7 @@
           <p:cNvPr id="3" name="">
             <a:extLst xmlns:a="http://schemas.openxmlformats.org/drawingml/2006/main">
               <a:ext uri="{FF2B5EF4-FFF2-40B4-BE49-F238E27FC236}">
-                <a16:creationId xmlns:a16="http://schemas.microsoft.com/office/drawing/2014/main" id="{3B0679A5-0508-42C9-BD38-4CE91A124070}"/>
+                <a16:creationId xmlns:a16="http://schemas.microsoft.com/office/drawing/2014/main" id="{FF4AE0F4-1903-4F72-928E-929FD5F54582}"/>
               </a:ext>
             </a:extLst>
           </p:cNvPr>
@@ -3930,7 +3930,7 @@
           <p:nvPr/>
         </p:nvPicPr>
         <p:blipFill>
-          <a:blip xmlns:r="http://schemas.openxmlformats.org/officeDocument/2006/relationships" xmlns:a="http://schemas.openxmlformats.org/drawingml/2006/main" r:embed="R6646f430df6a4833"/>
+          <a:blip xmlns:r="http://schemas.openxmlformats.org/officeDocument/2006/relationships" xmlns:a="http://schemas.openxmlformats.org/drawingml/2006/main" r:embed="Rab0d2b16fb7b4724"/>
           <a:stretch xmlns:a="http://schemas.openxmlformats.org/drawingml/2006/main"/>
         </p:blipFill>
         <p:spPr>
@@ -3945,10 +3945,10 @@
       </p:pic>
       <p:sp>
         <p:nvSpPr>
-          <p:cNvPr id="4" name="text-se39ke-2">
+          <p:cNvPr id="4" name="text-ensct8-2">
             <a:extLst xmlns:a="http://schemas.openxmlformats.org/drawingml/2006/main">
               <a:ext uri="{FF2B5EF4-FFF2-40B4-BE49-F238E27FC236}">
-                <a16:creationId xmlns:a16="http://schemas.microsoft.com/office/drawing/2014/main" id="{1E932F32-6A93-44F1-BE43-DEE506E04051}"/>
+                <a16:creationId xmlns:a16="http://schemas.microsoft.com/office/drawing/2014/main" id="{E62D0F9B-12EF-4B57-8F93-421D4F30D5F3}"/>
               </a:ext>
             </a:extLst>
           </p:cNvPr>
@@ -4036,10 +4036,10 @@
       </p:sp>
       <p:sp>
         <p:nvSpPr>
-          <p:cNvPr id="5" name="text-se39ke-3">
+          <p:cNvPr id="5" name="text-ensct8-3">
             <a:extLst xmlns:a="http://schemas.openxmlformats.org/drawingml/2006/main">
               <a:ext uri="{FF2B5EF4-FFF2-40B4-BE49-F238E27FC236}">
-                <a16:creationId xmlns:a16="http://schemas.microsoft.com/office/drawing/2014/main" id="{00B5BFDA-A34C-4284-84E7-95304EC3B09A}"/>
+                <a16:creationId xmlns:a16="http://schemas.microsoft.com/office/drawing/2014/main" id="{64BA7062-EE57-47DC-A616-1FF34C5941EE}"/>
               </a:ext>
             </a:extLst>
           </p:cNvPr>
@@ -4127,10 +4127,10 @@
       </p:sp>
       <p:sp>
         <p:nvSpPr>
-          <p:cNvPr id="6" name="text-se39ke-4">
+          <p:cNvPr id="6" name="text-ensct8-4">
             <a:extLst xmlns:a="http://schemas.openxmlformats.org/drawingml/2006/main">
               <a:ext uri="{FF2B5EF4-FFF2-40B4-BE49-F238E27FC236}">
-                <a16:creationId xmlns:a16="http://schemas.microsoft.com/office/drawing/2014/main" id="{27E1B7B1-982D-4934-A841-78051BF3C2BD}"/>
+                <a16:creationId xmlns:a16="http://schemas.microsoft.com/office/drawing/2014/main" id="{90C15268-D0EF-42FA-97C6-703C76D5245A}"/>
               </a:ext>
             </a:extLst>
           </p:cNvPr>
@@ -4195,10 +4195,10 @@
       </p:sp>
       <p:sp>
         <p:nvSpPr>
-          <p:cNvPr id="7" name="text-se39ke-5">
+          <p:cNvPr id="7" name="text-ensct8-5">
             <a:extLst xmlns:a="http://schemas.openxmlformats.org/drawingml/2006/main">
               <a:ext uri="{FF2B5EF4-FFF2-40B4-BE49-F238E27FC236}">
-                <a16:creationId xmlns:a16="http://schemas.microsoft.com/office/drawing/2014/main" id="{B472C3DD-9852-433B-9472-3EA4E5C56C5E}"/>
+                <a16:creationId xmlns:a16="http://schemas.microsoft.com/office/drawing/2014/main" id="{6514E58C-F28E-4F8D-B25F-0578FF5C1666}"/>
               </a:ext>
             </a:extLst>
           </p:cNvPr>
@@ -4264,7 +4264,7 @@
     </p:spTree>
     <p:extLst>
       <p:ext uri="{BB962C8B-B14F-4D97-AF65-F5344CB8AC3E}">
-        <p14:creationId xmlns:p14="http://schemas.microsoft.com/office/powerpoint/2010/main" val="762509827"/>
+        <p14:creationId xmlns:p14="http://schemas.microsoft.com/office/powerpoint/2010/main" val="880873286"/>
       </p:ext>
     </p:extLst>
   </p:cSld>
@@ -4292,10 +4292,10 @@
       </p:grpSpPr>
       <p:sp>
         <p:nvSpPr>
-          <p:cNvPr id="7" name="text-0ek4uv-0">
+          <p:cNvPr id="7" name="text-o2zthe-0">
             <a:extLst xmlns:a="http://schemas.openxmlformats.org/drawingml/2006/main">
               <a:ext uri="{FF2B5EF4-FFF2-40B4-BE49-F238E27FC236}">
-                <a16:creationId xmlns:a16="http://schemas.microsoft.com/office/drawing/2014/main" id="{CCB55C16-9AAD-41C1-9F41-4A51ED25CDE9}"/>
+                <a16:creationId xmlns:a16="http://schemas.microsoft.com/office/drawing/2014/main" id="{339AEFCC-206E-458F-899D-0F1F09B9FD78}"/>
               </a:ext>
             </a:extLst>
           </p:cNvPr>
@@ -4360,10 +4360,10 @@
       </p:sp>
       <p:sp>
         <p:nvSpPr>
-          <p:cNvPr id="2" name="text-0ek4uv-1">
+          <p:cNvPr id="2" name="text-o2zthe-1">
             <a:extLst xmlns:a="http://schemas.openxmlformats.org/drawingml/2006/main">
               <a:ext uri="{FF2B5EF4-FFF2-40B4-BE49-F238E27FC236}">
-                <a16:creationId xmlns:a16="http://schemas.microsoft.com/office/drawing/2014/main" id="{9BE2AD5E-F80F-4D4A-9B59-76B258B3BEA7}"/>
+                <a16:creationId xmlns:a16="http://schemas.microsoft.com/office/drawing/2014/main" id="{0B32F557-5655-4770-8D34-24056D26381D}"/>
               </a:ext>
             </a:extLst>
           </p:cNvPr>
@@ -4428,10 +4428,10 @@
       </p:sp>
       <p:sp>
         <p:nvSpPr>
-          <p:cNvPr id="3" name="text-0ek4uv-2">
+          <p:cNvPr id="3" name="text-o2zthe-2">
             <a:extLst xmlns:a="http://schemas.openxmlformats.org/drawingml/2006/main">
               <a:ext uri="{FF2B5EF4-FFF2-40B4-BE49-F238E27FC236}">
-                <a16:creationId xmlns:a16="http://schemas.microsoft.com/office/drawing/2014/main" id="{E0D12C1F-ED0F-4843-8AA8-FC7CA81D3BFB}"/>
+                <a16:creationId xmlns:a16="http://schemas.microsoft.com/office/drawing/2014/main" id="{FA8D5CF6-585C-4546-B907-F1D52C1286AF}"/>
               </a:ext>
             </a:extLst>
           </p:cNvPr>
@@ -4496,10 +4496,10 @@
       </p:sp>
       <p:sp>
         <p:nvSpPr>
-          <p:cNvPr id="4" name="text-0ek4uv-3">
+          <p:cNvPr id="4" name="text-o2zthe-3">
             <a:extLst xmlns:a="http://schemas.openxmlformats.org/drawingml/2006/main">
               <a:ext uri="{FF2B5EF4-FFF2-40B4-BE49-F238E27FC236}">
-                <a16:creationId xmlns:a16="http://schemas.microsoft.com/office/drawing/2014/main" id="{183AE634-3307-4A3A-A742-1EDF18CEEEF8}"/>
+                <a16:creationId xmlns:a16="http://schemas.microsoft.com/office/drawing/2014/main" id="{5316DC25-4A7D-4CAE-BC6A-7B9AE4FD1561}"/>
               </a:ext>
             </a:extLst>
           </p:cNvPr>
@@ -4567,7 +4567,7 @@
           <p:cNvPr id="5" name="">
             <a:extLst xmlns:a="http://schemas.openxmlformats.org/drawingml/2006/main">
               <a:ext uri="{FF2B5EF4-FFF2-40B4-BE49-F238E27FC236}">
-                <a16:creationId xmlns:a16="http://schemas.microsoft.com/office/drawing/2014/main" id="{29224CF1-3CB4-4751-A70A-00D48FCCB725}"/>
+                <a16:creationId xmlns:a16="http://schemas.microsoft.com/office/drawing/2014/main" id="{AD8B86AC-F1BE-49E1-ABBD-9A818312589A}"/>
               </a:ext>
             </a:extLst>
           </p:cNvPr>
@@ -4577,7 +4577,7 @@
           <p:nvPr/>
         </p:nvPicPr>
         <p:blipFill>
-          <a:blip xmlns:r="http://schemas.openxmlformats.org/officeDocument/2006/relationships" xmlns:a="http://schemas.openxmlformats.org/drawingml/2006/main" r:embed="R385637e6d3aa4e83"/>
+          <a:blip xmlns:r="http://schemas.openxmlformats.org/officeDocument/2006/relationships" xmlns:a="http://schemas.openxmlformats.org/drawingml/2006/main" r:embed="R6fdfb3986cce408e"/>
           <a:srcRect xmlns:a="http://schemas.openxmlformats.org/drawingml/2006/main" l="1953" t="17361" r="4297" b="26389"/>
           <a:stretch xmlns:a="http://schemas.openxmlformats.org/drawingml/2006/main"/>
         </p:blipFill>
@@ -4593,10 +4593,10 @@
       </p:pic>
       <p:sp>
         <p:nvSpPr>
-          <p:cNvPr id="6" name="text-0ek4uv-4">
+          <p:cNvPr id="6" name="text-o2zthe-4">
             <a:extLst xmlns:a="http://schemas.openxmlformats.org/drawingml/2006/main">
               <a:ext uri="{FF2B5EF4-FFF2-40B4-BE49-F238E27FC236}">
-                <a16:creationId xmlns:a16="http://schemas.microsoft.com/office/drawing/2014/main" id="{9FBA1C18-C9F5-4319-BBA5-EB8F8CC634D1}"/>
+                <a16:creationId xmlns:a16="http://schemas.microsoft.com/office/drawing/2014/main" id="{035A0308-782E-40D8-AA0A-A74C9095AEC7}"/>
               </a:ext>
             </a:extLst>
           </p:cNvPr>
@@ -4662,7 +4662,7 @@
     </p:spTree>
     <p:extLst>
       <p:ext uri="{BB962C8B-B14F-4D97-AF65-F5344CB8AC3E}">
-        <p14:creationId xmlns:p14="http://schemas.microsoft.com/office/powerpoint/2010/main" val="2067014778"/>
+        <p14:creationId xmlns:p14="http://schemas.microsoft.com/office/powerpoint/2010/main" val="1373491414"/>
       </p:ext>
     </p:extLst>
   </p:cSld>
@@ -4690,10 +4690,10 @@
       </p:grpSpPr>
       <p:sp>
         <p:nvSpPr>
-          <p:cNvPr id="7" name="text-0s5jd1-0">
+          <p:cNvPr id="7" name="text-hhuyp0-0">
             <a:extLst xmlns:a="http://schemas.openxmlformats.org/drawingml/2006/main">
               <a:ext uri="{FF2B5EF4-FFF2-40B4-BE49-F238E27FC236}">
-                <a16:creationId xmlns:a16="http://schemas.microsoft.com/office/drawing/2014/main" id="{335581C6-B458-42EB-89BA-B7A0398132C9}"/>
+                <a16:creationId xmlns:a16="http://schemas.microsoft.com/office/drawing/2014/main" id="{5C10BE30-F14D-435B-8F83-13446D81361B}"/>
               </a:ext>
             </a:extLst>
           </p:cNvPr>
@@ -4758,10 +4758,10 @@
       </p:sp>
       <p:sp>
         <p:nvSpPr>
-          <p:cNvPr id="2" name="text-0s5jd1-1">
+          <p:cNvPr id="2" name="text-hhuyp0-1">
             <a:extLst xmlns:a="http://schemas.openxmlformats.org/drawingml/2006/main">
               <a:ext uri="{FF2B5EF4-FFF2-40B4-BE49-F238E27FC236}">
-                <a16:creationId xmlns:a16="http://schemas.microsoft.com/office/drawing/2014/main" id="{C1D5DA96-13C9-4547-9425-2A5E4F40925E}"/>
+                <a16:creationId xmlns:a16="http://schemas.microsoft.com/office/drawing/2014/main" id="{CD38DAA6-7BB6-432F-B40A-0DB50B9DCF30}"/>
               </a:ext>
             </a:extLst>
           </p:cNvPr>
@@ -4826,10 +4826,10 @@
       </p:sp>
       <p:sp>
         <p:nvSpPr>
-          <p:cNvPr id="3" name="text-0s5jd1-2">
+          <p:cNvPr id="3" name="text-hhuyp0-2">
             <a:extLst xmlns:a="http://schemas.openxmlformats.org/drawingml/2006/main">
               <a:ext uri="{FF2B5EF4-FFF2-40B4-BE49-F238E27FC236}">
-                <a16:creationId xmlns:a16="http://schemas.microsoft.com/office/drawing/2014/main" id="{9D2125B5-E0A1-4C8B-A90E-4BE64F480C5F}"/>
+                <a16:creationId xmlns:a16="http://schemas.microsoft.com/office/drawing/2014/main" id="{597E67EA-284F-4A39-A632-F6694AB1E455}"/>
               </a:ext>
             </a:extLst>
           </p:cNvPr>
@@ -4894,10 +4894,10 @@
       </p:sp>
       <p:sp>
         <p:nvSpPr>
-          <p:cNvPr id="4" name="text-0s5jd1-3">
+          <p:cNvPr id="4" name="text-hhuyp0-3">
             <a:extLst xmlns:a="http://schemas.openxmlformats.org/drawingml/2006/main">
               <a:ext uri="{FF2B5EF4-FFF2-40B4-BE49-F238E27FC236}">
-                <a16:creationId xmlns:a16="http://schemas.microsoft.com/office/drawing/2014/main" id="{C3E40378-C6DB-42A3-8DE8-492779EC3A70}"/>
+                <a16:creationId xmlns:a16="http://schemas.microsoft.com/office/drawing/2014/main" id="{5849ED25-F55B-4890-AE83-FA24BB7C94B8}"/>
               </a:ext>
             </a:extLst>
           </p:cNvPr>
@@ -4965,7 +4965,7 @@
           <p:cNvPr id="5" name="">
             <a:extLst xmlns:a="http://schemas.openxmlformats.org/drawingml/2006/main">
               <a:ext uri="{FF2B5EF4-FFF2-40B4-BE49-F238E27FC236}">
-                <a16:creationId xmlns:a16="http://schemas.microsoft.com/office/drawing/2014/main" id="{D26B1B6C-C1D8-487C-9DBF-FC9D24862ABF}"/>
+                <a16:creationId xmlns:a16="http://schemas.microsoft.com/office/drawing/2014/main" id="{639590AD-5395-41EE-A913-80B9B59D2540}"/>
               </a:ext>
             </a:extLst>
           </p:cNvPr>
@@ -4975,7 +4975,7 @@
           <p:nvPr/>
         </p:nvPicPr>
         <p:blipFill>
-          <a:blip xmlns:r="http://schemas.openxmlformats.org/officeDocument/2006/relationships" xmlns:a="http://schemas.openxmlformats.org/drawingml/2006/main" r:embed="Rde1d6d9fbf8f46f0"/>
+          <a:blip xmlns:r="http://schemas.openxmlformats.org/officeDocument/2006/relationships" xmlns:a="http://schemas.openxmlformats.org/drawingml/2006/main" r:embed="Rdf900850b2ae424e"/>
           <a:srcRect xmlns:a="http://schemas.openxmlformats.org/drawingml/2006/main" l="4688" t="35417" r="4688" b="26806"/>
           <a:stretch xmlns:a="http://schemas.openxmlformats.org/drawingml/2006/main"/>
         </p:blipFill>
@@ -4991,10 +4991,10 @@
       </p:pic>
       <p:sp>
         <p:nvSpPr>
-          <p:cNvPr id="6" name="text-0s5jd1-4">
+          <p:cNvPr id="6" name="text-hhuyp0-4">
             <a:extLst xmlns:a="http://schemas.openxmlformats.org/drawingml/2006/main">
               <a:ext uri="{FF2B5EF4-FFF2-40B4-BE49-F238E27FC236}">
-                <a16:creationId xmlns:a16="http://schemas.microsoft.com/office/drawing/2014/main" id="{1D36604D-718F-4E5D-B0A0-B7D84C88D210}"/>
+                <a16:creationId xmlns:a16="http://schemas.microsoft.com/office/drawing/2014/main" id="{7C2D05BF-BAC0-4819-933E-B4DA72D580EF}"/>
               </a:ext>
             </a:extLst>
           </p:cNvPr>
@@ -5060,7 +5060,7 @@
     </p:spTree>
     <p:extLst>
       <p:ext uri="{BB962C8B-B14F-4D97-AF65-F5344CB8AC3E}">
-        <p14:creationId xmlns:p14="http://schemas.microsoft.com/office/powerpoint/2010/main" val="1167773918"/>
+        <p14:creationId xmlns:p14="http://schemas.microsoft.com/office/powerpoint/2010/main" val="952546463"/>
       </p:ext>
     </p:extLst>
   </p:cSld>
@@ -5088,10 +5088,10 @@
       </p:grpSpPr>
       <p:sp>
         <p:nvSpPr>
-          <p:cNvPr id="7" name="text-bdoxc0-0">
+          <p:cNvPr id="7" name="text-48eo0i-0">
             <a:extLst xmlns:a="http://schemas.openxmlformats.org/drawingml/2006/main">
               <a:ext uri="{FF2B5EF4-FFF2-40B4-BE49-F238E27FC236}">
-                <a16:creationId xmlns:a16="http://schemas.microsoft.com/office/drawing/2014/main" id="{EB66F9A7-D4B1-44D3-B70B-C746E099F9EC}"/>
+                <a16:creationId xmlns:a16="http://schemas.microsoft.com/office/drawing/2014/main" id="{D4A5D8CF-A542-420E-AD01-5C5C6DDC8E16}"/>
               </a:ext>
             </a:extLst>
           </p:cNvPr>
@@ -5156,10 +5156,10 @@
       </p:sp>
       <p:sp>
         <p:nvSpPr>
-          <p:cNvPr id="2" name="text-bdoxc0-1">
+          <p:cNvPr id="2" name="text-48eo0i-1">
             <a:extLst xmlns:a="http://schemas.openxmlformats.org/drawingml/2006/main">
               <a:ext uri="{FF2B5EF4-FFF2-40B4-BE49-F238E27FC236}">
-                <a16:creationId xmlns:a16="http://schemas.microsoft.com/office/drawing/2014/main" id="{9EFAE152-6DB0-4D56-B722-14E6158B9A6D}"/>
+                <a16:creationId xmlns:a16="http://schemas.microsoft.com/office/drawing/2014/main" id="{44DAE22C-B960-4D39-B5D1-FB7FC9172353}"/>
               </a:ext>
             </a:extLst>
           </p:cNvPr>
@@ -5224,10 +5224,10 @@
       </p:sp>
       <p:sp>
         <p:nvSpPr>
-          <p:cNvPr id="3" name="text-bdoxc0-2">
+          <p:cNvPr id="3" name="text-48eo0i-2">
             <a:extLst xmlns:a="http://schemas.openxmlformats.org/drawingml/2006/main">
               <a:ext uri="{FF2B5EF4-FFF2-40B4-BE49-F238E27FC236}">
-                <a16:creationId xmlns:a16="http://schemas.microsoft.com/office/drawing/2014/main" id="{AA747457-1F8E-4256-8EFE-003A02FE66A5}"/>
+                <a16:creationId xmlns:a16="http://schemas.microsoft.com/office/drawing/2014/main" id="{8DA40078-5774-4C03-93E8-35D00DADD6CB}"/>
               </a:ext>
             </a:extLst>
           </p:cNvPr>
@@ -5292,10 +5292,10 @@
       </p:sp>
       <p:sp>
         <p:nvSpPr>
-          <p:cNvPr id="4" name="text-bdoxc0-3">
+          <p:cNvPr id="4" name="text-48eo0i-3">
             <a:extLst xmlns:a="http://schemas.openxmlformats.org/drawingml/2006/main">
               <a:ext uri="{FF2B5EF4-FFF2-40B4-BE49-F238E27FC236}">
-                <a16:creationId xmlns:a16="http://schemas.microsoft.com/office/drawing/2014/main" id="{3C6C3E10-BF2B-4D3A-88E1-D7BCC5E88CA8}"/>
+                <a16:creationId xmlns:a16="http://schemas.microsoft.com/office/drawing/2014/main" id="{9EE333CB-3927-4B48-BBF3-D775BA42FF52}"/>
               </a:ext>
             </a:extLst>
           </p:cNvPr>
@@ -5363,7 +5363,7 @@
           <p:cNvPr id="5" name="">
             <a:extLst xmlns:a="http://schemas.openxmlformats.org/drawingml/2006/main">
               <a:ext uri="{FF2B5EF4-FFF2-40B4-BE49-F238E27FC236}">
-                <a16:creationId xmlns:a16="http://schemas.microsoft.com/office/drawing/2014/main" id="{8C6531CC-CC52-4AE4-A229-5435AC385980}"/>
+                <a16:creationId xmlns:a16="http://schemas.microsoft.com/office/drawing/2014/main" id="{1B3AE72C-3CDF-495A-9868-51178E45A7FB}"/>
               </a:ext>
             </a:extLst>
           </p:cNvPr>
@@ -6174,10 +6174,10 @@
       </p:graphicFrame>
       <p:sp>
         <p:nvSpPr>
-          <p:cNvPr id="6" name="text-bdoxc0-4">
+          <p:cNvPr id="6" name="text-48eo0i-4">
             <a:extLst xmlns:a="http://schemas.openxmlformats.org/drawingml/2006/main">
               <a:ext uri="{FF2B5EF4-FFF2-40B4-BE49-F238E27FC236}">
-                <a16:creationId xmlns:a16="http://schemas.microsoft.com/office/drawing/2014/main" id="{11183318-1624-48A1-8F9D-0999FCBA2DD1}"/>
+                <a16:creationId xmlns:a16="http://schemas.microsoft.com/office/drawing/2014/main" id="{887A49B4-8623-4FF8-B552-B8DBBA0893A4}"/>
               </a:ext>
             </a:extLst>
           </p:cNvPr>
@@ -6243,7 +6243,7 @@
     </p:spTree>
     <p:extLst>
       <p:ext uri="{BB962C8B-B14F-4D97-AF65-F5344CB8AC3E}">
-        <p14:creationId xmlns:p14="http://schemas.microsoft.com/office/powerpoint/2010/main" val="126488434"/>
+        <p14:creationId xmlns:p14="http://schemas.microsoft.com/office/powerpoint/2010/main" val="873245369"/>
       </p:ext>
     </p:extLst>
   </p:cSld>
@@ -6271,10 +6271,10 @@
       </p:grpSpPr>
       <p:sp>
         <p:nvSpPr>
-          <p:cNvPr id="16" name="text-x46fab-0">
+          <p:cNvPr id="16" name="text-j966ol-0">
             <a:extLst xmlns:a="http://schemas.openxmlformats.org/drawingml/2006/main">
               <a:ext uri="{FF2B5EF4-FFF2-40B4-BE49-F238E27FC236}">
-                <a16:creationId xmlns:a16="http://schemas.microsoft.com/office/drawing/2014/main" id="{D98AD4CE-5B85-4092-8E37-070A0A325EE1}"/>
+                <a16:creationId xmlns:a16="http://schemas.microsoft.com/office/drawing/2014/main" id="{51925F60-1CB0-4D25-9964-05F10A409D67}"/>
               </a:ext>
             </a:extLst>
           </p:cNvPr>
@@ -6339,10 +6339,10 @@
       </p:sp>
       <p:sp>
         <p:nvSpPr>
-          <p:cNvPr id="2" name="text-x46fab-1">
+          <p:cNvPr id="2" name="text-j966ol-1">
             <a:extLst xmlns:a="http://schemas.openxmlformats.org/drawingml/2006/main">
               <a:ext uri="{FF2B5EF4-FFF2-40B4-BE49-F238E27FC236}">
-                <a16:creationId xmlns:a16="http://schemas.microsoft.com/office/drawing/2014/main" id="{FAAB969B-ABFC-4223-8414-6C3C1F2D9D59}"/>
+                <a16:creationId xmlns:a16="http://schemas.microsoft.com/office/drawing/2014/main" id="{7811F21A-7C8B-4AE4-8A8C-C352F39424F6}"/>
               </a:ext>
             </a:extLst>
           </p:cNvPr>
@@ -6407,10 +6407,10 @@
       </p:sp>
       <p:sp>
         <p:nvSpPr>
-          <p:cNvPr id="3" name="text-x46fab-2">
+          <p:cNvPr id="3" name="text-j966ol-2">
             <a:extLst xmlns:a="http://schemas.openxmlformats.org/drawingml/2006/main">
               <a:ext uri="{FF2B5EF4-FFF2-40B4-BE49-F238E27FC236}">
-                <a16:creationId xmlns:a16="http://schemas.microsoft.com/office/drawing/2014/main" id="{0909ED70-DCE3-42E4-B0F0-7A7F195205DA}"/>
+                <a16:creationId xmlns:a16="http://schemas.microsoft.com/office/drawing/2014/main" id="{F6DB231D-E8AD-404E-865D-46DD1316AC20}"/>
               </a:ext>
             </a:extLst>
           </p:cNvPr>
@@ -6475,10 +6475,10 @@
       </p:sp>
       <p:sp>
         <p:nvSpPr>
-          <p:cNvPr id="4" name="text-x46fab-3">
+          <p:cNvPr id="4" name="text-j966ol-3">
             <a:extLst xmlns:a="http://schemas.openxmlformats.org/drawingml/2006/main">
               <a:ext uri="{FF2B5EF4-FFF2-40B4-BE49-F238E27FC236}">
-                <a16:creationId xmlns:a16="http://schemas.microsoft.com/office/drawing/2014/main" id="{EE2F3BC0-7F2A-47BB-8AA7-A49079378557}"/>
+                <a16:creationId xmlns:a16="http://schemas.microsoft.com/office/drawing/2014/main" id="{FC7A2AF5-F697-44E5-BA2A-E4925E57D58F}"/>
               </a:ext>
             </a:extLst>
           </p:cNvPr>
@@ -6543,10 +6543,10 @@
       </p:sp>
       <p:sp>
         <p:nvSpPr>
-          <p:cNvPr id="5" name="text-x46fab-4">
+          <p:cNvPr id="5" name="text-j966ol-4">
             <a:extLst xmlns:a="http://schemas.openxmlformats.org/drawingml/2006/main">
               <a:ext uri="{FF2B5EF4-FFF2-40B4-BE49-F238E27FC236}">
-                <a16:creationId xmlns:a16="http://schemas.microsoft.com/office/drawing/2014/main" id="{E8445A5F-BFCE-4CD1-B412-7DB62D9222D4}"/>
+                <a16:creationId xmlns:a16="http://schemas.microsoft.com/office/drawing/2014/main" id="{810E17B2-C606-41C5-BCFC-2C5EBB4AF232}"/>
               </a:ext>
             </a:extLst>
           </p:cNvPr>
@@ -6611,10 +6611,10 @@
       </p:sp>
       <p:sp>
         <p:nvSpPr>
-          <p:cNvPr id="6" name="text-x46fab-5">
+          <p:cNvPr id="6" name="text-j966ol-5">
             <a:extLst xmlns:a="http://schemas.openxmlformats.org/drawingml/2006/main">
               <a:ext uri="{FF2B5EF4-FFF2-40B4-BE49-F238E27FC236}">
-                <a16:creationId xmlns:a16="http://schemas.microsoft.com/office/drawing/2014/main" id="{C577CF65-EA39-4FC5-8642-43BB633BF238}"/>
+                <a16:creationId xmlns:a16="http://schemas.microsoft.com/office/drawing/2014/main" id="{BF7D6032-1BEC-4D07-A285-A64FB235CF38}"/>
               </a:ext>
             </a:extLst>
           </p:cNvPr>
@@ -6679,10 +6679,10 @@
       </p:sp>
       <p:sp>
         <p:nvSpPr>
-          <p:cNvPr id="7" name="text-x46fab-6">
+          <p:cNvPr id="7" name="text-j966ol-6">
             <a:extLst xmlns:a="http://schemas.openxmlformats.org/drawingml/2006/main">
               <a:ext uri="{FF2B5EF4-FFF2-40B4-BE49-F238E27FC236}">
-                <a16:creationId xmlns:a16="http://schemas.microsoft.com/office/drawing/2014/main" id="{04F130D6-5FFA-4F57-A407-AD6FCD6E4D35}"/>
+                <a16:creationId xmlns:a16="http://schemas.microsoft.com/office/drawing/2014/main" id="{5FED0E5D-A3F3-4772-B188-0C487E5B2066}"/>
               </a:ext>
             </a:extLst>
           </p:cNvPr>
@@ -6747,10 +6747,10 @@
       </p:sp>
       <p:sp>
         <p:nvSpPr>
-          <p:cNvPr id="8" name="text-x46fab-7">
+          <p:cNvPr id="8" name="text-j966ol-7">
             <a:extLst xmlns:a="http://schemas.openxmlformats.org/drawingml/2006/main">
               <a:ext uri="{FF2B5EF4-FFF2-40B4-BE49-F238E27FC236}">
-                <a16:creationId xmlns:a16="http://schemas.microsoft.com/office/drawing/2014/main" id="{3151FBF8-6803-4947-8358-A520B396B332}"/>
+                <a16:creationId xmlns:a16="http://schemas.microsoft.com/office/drawing/2014/main" id="{E694807E-F5E6-4EE2-8827-7F7A991E2884}"/>
               </a:ext>
             </a:extLst>
           </p:cNvPr>
@@ -6815,10 +6815,10 @@
       </p:sp>
       <p:sp>
         <p:nvSpPr>
-          <p:cNvPr id="9" name="text-x46fab-8">
+          <p:cNvPr id="9" name="text-j966ol-8">
             <a:extLst xmlns:a="http://schemas.openxmlformats.org/drawingml/2006/main">
               <a:ext uri="{FF2B5EF4-FFF2-40B4-BE49-F238E27FC236}">
-                <a16:creationId xmlns:a16="http://schemas.microsoft.com/office/drawing/2014/main" id="{DB95B1B9-17B1-4D0E-9FA7-19160DDC2864}"/>
+                <a16:creationId xmlns:a16="http://schemas.microsoft.com/office/drawing/2014/main" id="{A79184D1-E5DC-4E9E-A63B-5D31C74CF33B}"/>
               </a:ext>
             </a:extLst>
           </p:cNvPr>
@@ -6883,10 +6883,10 @@
       </p:sp>
       <p:sp>
         <p:nvSpPr>
-          <p:cNvPr id="10" name="text-x46fab-9">
+          <p:cNvPr id="10" name="text-j966ol-9">
             <a:extLst xmlns:a="http://schemas.openxmlformats.org/drawingml/2006/main">
               <a:ext uri="{FF2B5EF4-FFF2-40B4-BE49-F238E27FC236}">
-                <a16:creationId xmlns:a16="http://schemas.microsoft.com/office/drawing/2014/main" id="{EA6039BB-047A-40E8-A2FF-D23E68FEA81C}"/>
+                <a16:creationId xmlns:a16="http://schemas.microsoft.com/office/drawing/2014/main" id="{E914DA1C-ECEE-4425-9E32-A43EF580E863}"/>
               </a:ext>
             </a:extLst>
           </p:cNvPr>
@@ -6944,17 +6944,17 @@
                 <a:ea typeface="Arial"/>
                 <a:cs typeface="Arial"/>
               </a:rPr>
-              <a:t>Independent review and regression checks.</a:t>
-            </a:r>
-          </a:p>
-        </p:txBody>
-      </p:sp>
-      <p:sp>
-        <p:nvSpPr>
-          <p:cNvPr id="11" name="text-x46fab-10">
+              <a:t>Code review and regression checks.</a:t>
+            </a:r>
+          </a:p>
+        </p:txBody>
+      </p:sp>
+      <p:sp>
+        <p:nvSpPr>
+          <p:cNvPr id="11" name="text-j966ol-10">
             <a:extLst xmlns:a="http://schemas.openxmlformats.org/drawingml/2006/main">
               <a:ext uri="{FF2B5EF4-FFF2-40B4-BE49-F238E27FC236}">
-                <a16:creationId xmlns:a16="http://schemas.microsoft.com/office/drawing/2014/main" id="{1CB47F06-E88B-42F0-B66F-9B5B053B0228}"/>
+                <a16:creationId xmlns:a16="http://schemas.microsoft.com/office/drawing/2014/main" id="{9B261119-F607-4E73-B630-9BC7AFD0092E}"/>
               </a:ext>
             </a:extLst>
           </p:cNvPr>
@@ -7019,10 +7019,10 @@
       </p:sp>
       <p:sp>
         <p:nvSpPr>
-          <p:cNvPr id="12" name="text-x46fab-11">
+          <p:cNvPr id="12" name="text-j966ol-11">
             <a:extLst xmlns:a="http://schemas.openxmlformats.org/drawingml/2006/main">
               <a:ext uri="{FF2B5EF4-FFF2-40B4-BE49-F238E27FC236}">
-                <a16:creationId xmlns:a16="http://schemas.microsoft.com/office/drawing/2014/main" id="{3AB474D2-C134-42FF-8A76-42235C75A5C2}"/>
+                <a16:creationId xmlns:a16="http://schemas.microsoft.com/office/drawing/2014/main" id="{35F4039B-802C-4692-8E62-3F982C7CA397}"/>
               </a:ext>
             </a:extLst>
           </p:cNvPr>
@@ -7110,10 +7110,10 @@
       </p:sp>
       <p:sp>
         <p:nvSpPr>
-          <p:cNvPr id="13" name="text-x46fab-12">
+          <p:cNvPr id="13" name="text-j966ol-12">
             <a:extLst xmlns:a="http://schemas.openxmlformats.org/drawingml/2006/main">
               <a:ext uri="{FF2B5EF4-FFF2-40B4-BE49-F238E27FC236}">
-                <a16:creationId xmlns:a16="http://schemas.microsoft.com/office/drawing/2014/main" id="{2060111A-88F6-4C7B-8E4F-11A74E21D8E7}"/>
+                <a16:creationId xmlns:a16="http://schemas.microsoft.com/office/drawing/2014/main" id="{A2A7AB71-28B1-4239-BA2D-D7966CB4D008}"/>
               </a:ext>
             </a:extLst>
           </p:cNvPr>
@@ -7178,10 +7178,10 @@
       </p:sp>
       <p:sp>
         <p:nvSpPr>
-          <p:cNvPr id="14" name="text-x46fab-13">
+          <p:cNvPr id="14" name="text-j966ol-13">
             <a:extLst xmlns:a="http://schemas.openxmlformats.org/drawingml/2006/main">
               <a:ext uri="{FF2B5EF4-FFF2-40B4-BE49-F238E27FC236}">
-                <a16:creationId xmlns:a16="http://schemas.microsoft.com/office/drawing/2014/main" id="{89B7C6C0-4A69-4443-BCF4-495B6BE57971}"/>
+                <a16:creationId xmlns:a16="http://schemas.microsoft.com/office/drawing/2014/main" id="{2ED6AA3B-683A-4096-91F6-DAFE447C9423}"/>
               </a:ext>
             </a:extLst>
           </p:cNvPr>
@@ -7269,10 +7269,10 @@
       </p:sp>
       <p:sp>
         <p:nvSpPr>
-          <p:cNvPr id="15" name="text-x46fab-14">
+          <p:cNvPr id="15" name="text-j966ol-14">
             <a:extLst xmlns:a="http://schemas.openxmlformats.org/drawingml/2006/main">
               <a:ext uri="{FF2B5EF4-FFF2-40B4-BE49-F238E27FC236}">
-                <a16:creationId xmlns:a16="http://schemas.microsoft.com/office/drawing/2014/main" id="{4BE0E683-94E2-4127-BE04-337607A9139B}"/>
+                <a16:creationId xmlns:a16="http://schemas.microsoft.com/office/drawing/2014/main" id="{722A0787-6573-4A27-81AB-FF27DD0983BD}"/>
               </a:ext>
             </a:extLst>
           </p:cNvPr>
@@ -7338,7 +7338,7 @@
     </p:spTree>
     <p:extLst>
       <p:ext uri="{BB962C8B-B14F-4D97-AF65-F5344CB8AC3E}">
-        <p14:creationId xmlns:p14="http://schemas.microsoft.com/office/powerpoint/2010/main" val="58120322"/>
+        <p14:creationId xmlns:p14="http://schemas.microsoft.com/office/powerpoint/2010/main" val="1249374604"/>
       </p:ext>
     </p:extLst>
   </p:cSld>
@@ -7366,10 +7366,10 @@
       </p:grpSpPr>
       <p:sp>
         <p:nvSpPr>
-          <p:cNvPr id="15" name="text-9l2z2h-0">
+          <p:cNvPr id="15" name="text-ez671b-0">
             <a:extLst xmlns:a="http://schemas.openxmlformats.org/drawingml/2006/main">
               <a:ext uri="{FF2B5EF4-FFF2-40B4-BE49-F238E27FC236}">
-                <a16:creationId xmlns:a16="http://schemas.microsoft.com/office/drawing/2014/main" id="{7B0F0F06-BA08-4653-A00E-766EA77DD6F9}"/>
+                <a16:creationId xmlns:a16="http://schemas.microsoft.com/office/drawing/2014/main" id="{25A63F21-6A9E-4018-97D1-77EDE0BC8974}"/>
               </a:ext>
             </a:extLst>
           </p:cNvPr>
@@ -7434,10 +7434,10 @@
       </p:sp>
       <p:sp>
         <p:nvSpPr>
-          <p:cNvPr id="2" name="text-9l2z2h-1">
+          <p:cNvPr id="2" name="text-ez671b-1">
             <a:extLst xmlns:a="http://schemas.openxmlformats.org/drawingml/2006/main">
               <a:ext uri="{FF2B5EF4-FFF2-40B4-BE49-F238E27FC236}">
-                <a16:creationId xmlns:a16="http://schemas.microsoft.com/office/drawing/2014/main" id="{9E16C802-336C-4FF2-A1C7-8402EAA1719C}"/>
+                <a16:creationId xmlns:a16="http://schemas.microsoft.com/office/drawing/2014/main" id="{EE5EDFC9-B3E3-4FA9-BE4E-7426660F1563}"/>
               </a:ext>
             </a:extLst>
           </p:cNvPr>
@@ -7502,10 +7502,10 @@
       </p:sp>
       <p:sp>
         <p:nvSpPr>
-          <p:cNvPr id="3" name="text-9l2z2h-2">
+          <p:cNvPr id="3" name="text-ez671b-2">
             <a:extLst xmlns:a="http://schemas.openxmlformats.org/drawingml/2006/main">
               <a:ext uri="{FF2B5EF4-FFF2-40B4-BE49-F238E27FC236}">
-                <a16:creationId xmlns:a16="http://schemas.microsoft.com/office/drawing/2014/main" id="{C327ACA8-0BB4-4217-8C21-783EF45E69F1}"/>
+                <a16:creationId xmlns:a16="http://schemas.microsoft.com/office/drawing/2014/main" id="{164E2B4F-F33A-41B6-9BD8-46BFCDE0BE3E}"/>
               </a:ext>
             </a:extLst>
           </p:cNvPr>
@@ -7570,10 +7570,10 @@
       </p:sp>
       <p:sp>
         <p:nvSpPr>
-          <p:cNvPr id="4" name="text-9l2z2h-3">
+          <p:cNvPr id="4" name="text-ez671b-3">
             <a:extLst xmlns:a="http://schemas.openxmlformats.org/drawingml/2006/main">
               <a:ext uri="{FF2B5EF4-FFF2-40B4-BE49-F238E27FC236}">
-                <a16:creationId xmlns:a16="http://schemas.microsoft.com/office/drawing/2014/main" id="{9272DCE4-82E3-42A6-87B6-45B01E18D387}"/>
+                <a16:creationId xmlns:a16="http://schemas.microsoft.com/office/drawing/2014/main" id="{EF1FF62E-8ADE-4DC0-8C67-621870805AE9}"/>
               </a:ext>
             </a:extLst>
           </p:cNvPr>
@@ -7638,10 +7638,10 @@
       </p:sp>
       <p:sp>
         <p:nvSpPr>
-          <p:cNvPr id="5" name="text-9l2z2h-4">
+          <p:cNvPr id="5" name="text-ez671b-4">
             <a:extLst xmlns:a="http://schemas.openxmlformats.org/drawingml/2006/main">
               <a:ext uri="{FF2B5EF4-FFF2-40B4-BE49-F238E27FC236}">
-                <a16:creationId xmlns:a16="http://schemas.microsoft.com/office/drawing/2014/main" id="{55B737D8-711B-42D2-9DD6-39261CF43510}"/>
+                <a16:creationId xmlns:a16="http://schemas.microsoft.com/office/drawing/2014/main" id="{D6739329-850B-4CA8-9EB4-97D7952AE199}"/>
               </a:ext>
             </a:extLst>
           </p:cNvPr>
@@ -7706,10 +7706,10 @@
       </p:sp>
       <p:sp>
         <p:nvSpPr>
-          <p:cNvPr id="6" name="text-9l2z2h-5">
+          <p:cNvPr id="6" name="text-ez671b-5">
             <a:extLst xmlns:a="http://schemas.openxmlformats.org/drawingml/2006/main">
               <a:ext uri="{FF2B5EF4-FFF2-40B4-BE49-F238E27FC236}">
-                <a16:creationId xmlns:a16="http://schemas.microsoft.com/office/drawing/2014/main" id="{334595D1-E465-44C9-98D5-3BBA0CF21EE2}"/>
+                <a16:creationId xmlns:a16="http://schemas.microsoft.com/office/drawing/2014/main" id="{FA52DF02-6AD9-4A9F-9142-383117C6F2F0}"/>
               </a:ext>
             </a:extLst>
           </p:cNvPr>
@@ -7797,10 +7797,10 @@
       </p:sp>
       <p:sp>
         <p:nvSpPr>
-          <p:cNvPr id="7" name="text-9l2z2h-6">
+          <p:cNvPr id="7" name="text-ez671b-6">
             <a:extLst xmlns:a="http://schemas.openxmlformats.org/drawingml/2006/main">
               <a:ext uri="{FF2B5EF4-FFF2-40B4-BE49-F238E27FC236}">
-                <a16:creationId xmlns:a16="http://schemas.microsoft.com/office/drawing/2014/main" id="{B0029015-C6CF-452B-A09A-88F1A6952860}"/>
+                <a16:creationId xmlns:a16="http://schemas.microsoft.com/office/drawing/2014/main" id="{1F01FCBE-1957-4000-B5A8-0CFB48698695}"/>
               </a:ext>
             </a:extLst>
           </p:cNvPr>
@@ -7865,10 +7865,10 @@
       </p:sp>
       <p:sp>
         <p:nvSpPr>
-          <p:cNvPr id="8" name="text-9l2z2h-7">
+          <p:cNvPr id="8" name="text-ez671b-7">
             <a:extLst xmlns:a="http://schemas.openxmlformats.org/drawingml/2006/main">
               <a:ext uri="{FF2B5EF4-FFF2-40B4-BE49-F238E27FC236}">
-                <a16:creationId xmlns:a16="http://schemas.microsoft.com/office/drawing/2014/main" id="{221670A3-A23F-4C25-B625-391FC5DDF0AC}"/>
+                <a16:creationId xmlns:a16="http://schemas.microsoft.com/office/drawing/2014/main" id="{0680BEE7-026B-440B-925F-85F75EC92D51}"/>
               </a:ext>
             </a:extLst>
           </p:cNvPr>
@@ -7956,10 +7956,10 @@
       </p:sp>
       <p:sp>
         <p:nvSpPr>
-          <p:cNvPr id="9" name="text-9l2z2h-8">
+          <p:cNvPr id="9" name="text-ez671b-8">
             <a:extLst xmlns:a="http://schemas.openxmlformats.org/drawingml/2006/main">
               <a:ext uri="{FF2B5EF4-FFF2-40B4-BE49-F238E27FC236}">
-                <a16:creationId xmlns:a16="http://schemas.microsoft.com/office/drawing/2014/main" id="{3645D040-D133-4B93-B974-EB75B3FA68B7}"/>
+                <a16:creationId xmlns:a16="http://schemas.microsoft.com/office/drawing/2014/main" id="{D169815C-275C-4698-BA99-01CB08AA666C}"/>
               </a:ext>
             </a:extLst>
           </p:cNvPr>
@@ -8024,10 +8024,10 @@
       </p:sp>
       <p:sp>
         <p:nvSpPr>
-          <p:cNvPr id="10" name="text-9l2z2h-9">
+          <p:cNvPr id="10" name="text-ez671b-9">
             <a:extLst xmlns:a="http://schemas.openxmlformats.org/drawingml/2006/main">
               <a:ext uri="{FF2B5EF4-FFF2-40B4-BE49-F238E27FC236}">
-                <a16:creationId xmlns:a16="http://schemas.microsoft.com/office/drawing/2014/main" id="{7F3B598F-FFEF-4AAC-81BD-BD001538406C}"/>
+                <a16:creationId xmlns:a16="http://schemas.microsoft.com/office/drawing/2014/main" id="{098A3227-B31B-49AB-BE27-94DA64E94129}"/>
               </a:ext>
             </a:extLst>
           </p:cNvPr>
@@ -8115,10 +8115,10 @@
       </p:sp>
       <p:sp>
         <p:nvSpPr>
-          <p:cNvPr id="11" name="text-9l2z2h-10">
+          <p:cNvPr id="11" name="text-ez671b-10">
             <a:extLst xmlns:a="http://schemas.openxmlformats.org/drawingml/2006/main">
               <a:ext uri="{FF2B5EF4-FFF2-40B4-BE49-F238E27FC236}">
-                <a16:creationId xmlns:a16="http://schemas.microsoft.com/office/drawing/2014/main" id="{7FA17C50-1003-4924-B52D-76BC31ECAD13}"/>
+                <a16:creationId xmlns:a16="http://schemas.microsoft.com/office/drawing/2014/main" id="{59E4BD55-F283-4C16-B6B0-5544B9F5A40D}"/>
               </a:ext>
             </a:extLst>
           </p:cNvPr>
@@ -8183,10 +8183,10 @@
       </p:sp>
       <p:sp>
         <p:nvSpPr>
-          <p:cNvPr id="12" name="text-9l2z2h-11">
+          <p:cNvPr id="12" name="text-ez671b-11">
             <a:extLst xmlns:a="http://schemas.openxmlformats.org/drawingml/2006/main">
               <a:ext uri="{FF2B5EF4-FFF2-40B4-BE49-F238E27FC236}">
-                <a16:creationId xmlns:a16="http://schemas.microsoft.com/office/drawing/2014/main" id="{6CDC5D6C-36A3-42D2-8336-4C3C424CE2A0}"/>
+                <a16:creationId xmlns:a16="http://schemas.microsoft.com/office/drawing/2014/main" id="{0A4F4466-9DE0-4181-9D8C-353FAB4B3901}"/>
               </a:ext>
             </a:extLst>
           </p:cNvPr>
@@ -8254,19 +8254,19 @@
                 <a:latin typeface="Arial"/>
                 <a:ea typeface="Arial"/>
                 <a:cs typeface="Arial"/>
-                <a:hlinkClick xmlns:r="http://schemas.openxmlformats.org/officeDocument/2006/relationships" r:id="R4637da1f5b794b6a"/>
+                <a:hlinkClick xmlns:r="http://schemas.openxmlformats.org/officeDocument/2006/relationships" r:id="R36e8946e84964a5d"/>
               </a:rPr>
-              <a:t>GitHub (private)</a:t>
-            </a:r>
-          </a:p>
-        </p:txBody>
-      </p:sp>
-      <p:sp>
-        <p:nvSpPr>
-          <p:cNvPr id="13" name="text-9l2z2h-12">
+              <a:t>GitHub</a:t>
+            </a:r>
+          </a:p>
+        </p:txBody>
+      </p:sp>
+      <p:sp>
+        <p:nvSpPr>
+          <p:cNvPr id="13" name="text-ez671b-12">
             <a:extLst xmlns:a="http://schemas.openxmlformats.org/drawingml/2006/main">
               <a:ext uri="{FF2B5EF4-FFF2-40B4-BE49-F238E27FC236}">
-                <a16:creationId xmlns:a16="http://schemas.microsoft.com/office/drawing/2014/main" id="{E3914032-CB36-4CF0-8806-3F5B975CEA2B}"/>
+                <a16:creationId xmlns:a16="http://schemas.microsoft.com/office/drawing/2014/main" id="{3DDECA49-3A80-4C58-A452-F40D4463B75C}"/>
               </a:ext>
             </a:extLst>
           </p:cNvPr>
@@ -8324,17 +8324,17 @@
                 <a:ea typeface="Arial"/>
                 <a:cs typeface="Arial"/>
               </a:rPr>
-              <a:t>Repository access required.</a:t>
-            </a:r>
-          </a:p>
-        </p:txBody>
-      </p:sp>
-      <p:sp>
-        <p:nvSpPr>
-          <p:cNvPr id="14" name="text-9l2z2h-13">
+              <a:t>Source code on GitHub</a:t>
+            </a:r>
+          </a:p>
+        </p:txBody>
+      </p:sp>
+      <p:sp>
+        <p:nvSpPr>
+          <p:cNvPr id="14" name="text-ez671b-13">
             <a:extLst xmlns:a="http://schemas.openxmlformats.org/drawingml/2006/main">
               <a:ext uri="{FF2B5EF4-FFF2-40B4-BE49-F238E27FC236}">
-                <a16:creationId xmlns:a16="http://schemas.microsoft.com/office/drawing/2014/main" id="{D635E4E7-870C-4A07-A872-1ECDBA7896D3}"/>
+                <a16:creationId xmlns:a16="http://schemas.microsoft.com/office/drawing/2014/main" id="{671C15CF-3E1B-4CC1-A097-EB2F2B66078B}"/>
               </a:ext>
             </a:extLst>
           </p:cNvPr>
@@ -8392,7 +8392,7 @@
                 <a:ea typeface="Arial"/>
                 <a:cs typeface="Arial"/>
               </a:rPr>
-              <a:t>Synthetic demo. No production deployment. CI follow-up remains open.</a:t>
+              <a:t>Synthetic demo. No production deployment.</a:t>
             </a:r>
           </a:p>
         </p:txBody>
@@ -8400,7 +8400,7 @@
     </p:spTree>
     <p:extLst>
       <p:ext uri="{BB962C8B-B14F-4D97-AF65-F5344CB8AC3E}">
-        <p14:creationId xmlns:p14="http://schemas.microsoft.com/office/powerpoint/2010/main" val="1451757476"/>
+        <p14:creationId xmlns:p14="http://schemas.microsoft.com/office/powerpoint/2010/main" val="1023856518"/>
       </p:ext>
     </p:extLst>
   </p:cSld>
@@ -8428,10 +8428,10 @@
       </p:grpSpPr>
       <p:sp>
         <p:nvSpPr>
-          <p:cNvPr id="13" name="text-gdrbs0-0">
+          <p:cNvPr id="13" name="text-0jql32-0">
             <a:extLst xmlns:a="http://schemas.openxmlformats.org/drawingml/2006/main">
               <a:ext uri="{FF2B5EF4-FFF2-40B4-BE49-F238E27FC236}">
-                <a16:creationId xmlns:a16="http://schemas.microsoft.com/office/drawing/2014/main" id="{E6F1883F-398A-41BF-AE71-F8EDF6CA2414}"/>
+                <a16:creationId xmlns:a16="http://schemas.microsoft.com/office/drawing/2014/main" id="{591601AB-1ABB-4553-B807-95F1B4397B89}"/>
               </a:ext>
             </a:extLst>
           </p:cNvPr>
@@ -8496,10 +8496,10 @@
       </p:sp>
       <p:sp>
         <p:nvSpPr>
-          <p:cNvPr id="2" name="text-gdrbs0-1">
+          <p:cNvPr id="2" name="text-0jql32-1">
             <a:extLst xmlns:a="http://schemas.openxmlformats.org/drawingml/2006/main">
               <a:ext uri="{FF2B5EF4-FFF2-40B4-BE49-F238E27FC236}">
-                <a16:creationId xmlns:a16="http://schemas.microsoft.com/office/drawing/2014/main" id="{B944475A-3EC5-45EA-95F5-BC910275EF76}"/>
+                <a16:creationId xmlns:a16="http://schemas.microsoft.com/office/drawing/2014/main" id="{5072EF16-9974-476B-809B-F97C8D24BAE9}"/>
               </a:ext>
             </a:extLst>
           </p:cNvPr>
@@ -8564,10 +8564,10 @@
       </p:sp>
       <p:sp>
         <p:nvSpPr>
-          <p:cNvPr id="3" name="text-gdrbs0-2">
+          <p:cNvPr id="3" name="text-0jql32-2">
             <a:extLst xmlns:a="http://schemas.openxmlformats.org/drawingml/2006/main">
               <a:ext uri="{FF2B5EF4-FFF2-40B4-BE49-F238E27FC236}">
-                <a16:creationId xmlns:a16="http://schemas.microsoft.com/office/drawing/2014/main" id="{0A14E206-3809-43FA-B554-ED9F01BEBA60}"/>
+                <a16:creationId xmlns:a16="http://schemas.microsoft.com/office/drawing/2014/main" id="{A506D92D-9600-4388-AE14-766B0D5A5487}"/>
               </a:ext>
             </a:extLst>
           </p:cNvPr>
@@ -8632,10 +8632,10 @@
       </p:sp>
       <p:sp>
         <p:nvSpPr>
-          <p:cNvPr id="4" name="text-gdrbs0-3">
+          <p:cNvPr id="4" name="text-0jql32-3">
             <a:extLst xmlns:a="http://schemas.openxmlformats.org/drawingml/2006/main">
               <a:ext uri="{FF2B5EF4-FFF2-40B4-BE49-F238E27FC236}">
-                <a16:creationId xmlns:a16="http://schemas.microsoft.com/office/drawing/2014/main" id="{6B0710D6-F5E9-4AE4-B3FB-E285F494876B}"/>
+                <a16:creationId xmlns:a16="http://schemas.microsoft.com/office/drawing/2014/main" id="{9F70C671-00F5-4C61-A1E7-F55F3E5DD734}"/>
               </a:ext>
             </a:extLst>
           </p:cNvPr>
@@ -8700,10 +8700,10 @@
       </p:sp>
       <p:sp>
         <p:nvSpPr>
-          <p:cNvPr id="5" name="text-gdrbs0-4">
+          <p:cNvPr id="5" name="text-0jql32-4">
             <a:extLst xmlns:a="http://schemas.openxmlformats.org/drawingml/2006/main">
               <a:ext uri="{FF2B5EF4-FFF2-40B4-BE49-F238E27FC236}">
-                <a16:creationId xmlns:a16="http://schemas.microsoft.com/office/drawing/2014/main" id="{9EE9BF2A-68EA-493F-92A4-51C35BB1E59A}"/>
+                <a16:creationId xmlns:a16="http://schemas.microsoft.com/office/drawing/2014/main" id="{03935928-4A73-45CC-907D-D9B9E8162020}"/>
               </a:ext>
             </a:extLst>
           </p:cNvPr>
@@ -8768,10 +8768,10 @@
       </p:sp>
       <p:sp>
         <p:nvSpPr>
-          <p:cNvPr id="6" name="text-gdrbs0-5">
+          <p:cNvPr id="6" name="text-0jql32-5">
             <a:extLst xmlns:a="http://schemas.openxmlformats.org/drawingml/2006/main">
               <a:ext uri="{FF2B5EF4-FFF2-40B4-BE49-F238E27FC236}">
-                <a16:creationId xmlns:a16="http://schemas.microsoft.com/office/drawing/2014/main" id="{B7FE9142-9655-4078-8E6C-1D00C7470946}"/>
+                <a16:creationId xmlns:a16="http://schemas.microsoft.com/office/drawing/2014/main" id="{F3F8A454-AC7E-4405-80E2-C9E183582E54}"/>
               </a:ext>
             </a:extLst>
           </p:cNvPr>
@@ -8836,10 +8836,10 @@
       </p:sp>
       <p:sp>
         <p:nvSpPr>
-          <p:cNvPr id="7" name="text-gdrbs0-6">
+          <p:cNvPr id="7" name="text-0jql32-6">
             <a:extLst xmlns:a="http://schemas.openxmlformats.org/drawingml/2006/main">
               <a:ext uri="{FF2B5EF4-FFF2-40B4-BE49-F238E27FC236}">
-                <a16:creationId xmlns:a16="http://schemas.microsoft.com/office/drawing/2014/main" id="{0175C234-0C26-4F31-BFFE-81380B73E434}"/>
+                <a16:creationId xmlns:a16="http://schemas.microsoft.com/office/drawing/2014/main" id="{16F02E57-78AD-40AE-81DC-7618760595DF}"/>
               </a:ext>
             </a:extLst>
           </p:cNvPr>
@@ -8904,10 +8904,10 @@
       </p:sp>
       <p:sp>
         <p:nvSpPr>
-          <p:cNvPr id="8" name="text-gdrbs0-7">
+          <p:cNvPr id="8" name="text-0jql32-7">
             <a:extLst xmlns:a="http://schemas.openxmlformats.org/drawingml/2006/main">
               <a:ext uri="{FF2B5EF4-FFF2-40B4-BE49-F238E27FC236}">
-                <a16:creationId xmlns:a16="http://schemas.microsoft.com/office/drawing/2014/main" id="{80CB3BF4-0FA7-41EF-86A9-A48467D36D30}"/>
+                <a16:creationId xmlns:a16="http://schemas.microsoft.com/office/drawing/2014/main" id="{6873225C-4F9E-456E-B360-024503DF2D9F}"/>
               </a:ext>
             </a:extLst>
           </p:cNvPr>
@@ -8972,10 +8972,10 @@
       </p:sp>
       <p:sp>
         <p:nvSpPr>
-          <p:cNvPr id="9" name="text-gdrbs0-8">
+          <p:cNvPr id="9" name="text-0jql32-8">
             <a:extLst xmlns:a="http://schemas.openxmlformats.org/drawingml/2006/main">
               <a:ext uri="{FF2B5EF4-FFF2-40B4-BE49-F238E27FC236}">
-                <a16:creationId xmlns:a16="http://schemas.microsoft.com/office/drawing/2014/main" id="{76FE41C2-0540-4B5D-A8A5-34CED3026F6D}"/>
+                <a16:creationId xmlns:a16="http://schemas.microsoft.com/office/drawing/2014/main" id="{C403C7E4-9579-44EA-AB77-153FBBB6EB70}"/>
               </a:ext>
             </a:extLst>
           </p:cNvPr>
@@ -9040,10 +9040,10 @@
       </p:sp>
       <p:sp>
         <p:nvSpPr>
-          <p:cNvPr id="10" name="text-gdrbs0-9">
+          <p:cNvPr id="10" name="text-0jql32-9">
             <a:extLst xmlns:a="http://schemas.openxmlformats.org/drawingml/2006/main">
               <a:ext uri="{FF2B5EF4-FFF2-40B4-BE49-F238E27FC236}">
-                <a16:creationId xmlns:a16="http://schemas.microsoft.com/office/drawing/2014/main" id="{B072C045-1F61-4CF0-8048-43884A1B131B}"/>
+                <a16:creationId xmlns:a16="http://schemas.microsoft.com/office/drawing/2014/main" id="{991E17E9-ADEA-49C9-8628-3912651AC578}"/>
               </a:ext>
             </a:extLst>
           </p:cNvPr>
@@ -9108,10 +9108,10 @@
       </p:sp>
       <p:sp>
         <p:nvSpPr>
-          <p:cNvPr id="11" name="text-gdrbs0-10">
+          <p:cNvPr id="11" name="text-0jql32-10">
             <a:extLst xmlns:a="http://schemas.openxmlformats.org/drawingml/2006/main">
               <a:ext uri="{FF2B5EF4-FFF2-40B4-BE49-F238E27FC236}">
-                <a16:creationId xmlns:a16="http://schemas.microsoft.com/office/drawing/2014/main" id="{4F4164C7-8900-4105-A6BD-679E82AA6258}"/>
+                <a16:creationId xmlns:a16="http://schemas.microsoft.com/office/drawing/2014/main" id="{22B11202-DF95-42D8-A262-59E414BF3194}"/>
               </a:ext>
             </a:extLst>
           </p:cNvPr>
@@ -9176,10 +9176,10 @@
       </p:sp>
       <p:sp>
         <p:nvSpPr>
-          <p:cNvPr id="12" name="text-gdrbs0-11">
+          <p:cNvPr id="12" name="text-0jql32-11">
             <a:extLst xmlns:a="http://schemas.openxmlformats.org/drawingml/2006/main">
               <a:ext uri="{FF2B5EF4-FFF2-40B4-BE49-F238E27FC236}">
-                <a16:creationId xmlns:a16="http://schemas.microsoft.com/office/drawing/2014/main" id="{98C7C486-8EE2-4342-AE7E-7C496881C939}"/>
+                <a16:creationId xmlns:a16="http://schemas.microsoft.com/office/drawing/2014/main" id="{45187756-7486-46F3-8241-9B9124C93EFD}"/>
               </a:ext>
             </a:extLst>
           </p:cNvPr>
@@ -9245,7 +9245,7 @@
     </p:spTree>
     <p:extLst>
       <p:ext uri="{BB962C8B-B14F-4D97-AF65-F5344CB8AC3E}">
-        <p14:creationId xmlns:p14="http://schemas.microsoft.com/office/powerpoint/2010/main" val="440662839"/>
+        <p14:creationId xmlns:p14="http://schemas.microsoft.com/office/powerpoint/2010/main" val="901756031"/>
       </p:ext>
     </p:extLst>
   </p:cSld>
@@ -9273,10 +9273,10 @@
       </p:grpSpPr>
       <p:sp>
         <p:nvSpPr>
-          <p:cNvPr id="20" name="text-n5kf9o-0">
+          <p:cNvPr id="20" name="text-dflj47-0">
             <a:extLst xmlns:a="http://schemas.openxmlformats.org/drawingml/2006/main">
               <a:ext uri="{FF2B5EF4-FFF2-40B4-BE49-F238E27FC236}">
-                <a16:creationId xmlns:a16="http://schemas.microsoft.com/office/drawing/2014/main" id="{D128374F-AF6C-4208-95B7-C53562161006}"/>
+                <a16:creationId xmlns:a16="http://schemas.microsoft.com/office/drawing/2014/main" id="{FC0B2C74-E050-4055-B518-7A18033E67B3}"/>
               </a:ext>
             </a:extLst>
           </p:cNvPr>
@@ -9341,10 +9341,10 @@
       </p:sp>
       <p:sp>
         <p:nvSpPr>
-          <p:cNvPr id="2" name="text-n5kf9o-1">
+          <p:cNvPr id="2" name="text-dflj47-1">
             <a:extLst xmlns:a="http://schemas.openxmlformats.org/drawingml/2006/main">
               <a:ext uri="{FF2B5EF4-FFF2-40B4-BE49-F238E27FC236}">
-                <a16:creationId xmlns:a16="http://schemas.microsoft.com/office/drawing/2014/main" id="{678ADA07-5919-427F-B911-11AB2E505247}"/>
+                <a16:creationId xmlns:a16="http://schemas.microsoft.com/office/drawing/2014/main" id="{57A604BF-DAA7-402D-BCC3-E5CB1315A788}"/>
               </a:ext>
             </a:extLst>
           </p:cNvPr>
@@ -9409,10 +9409,10 @@
       </p:sp>
       <p:sp>
         <p:nvSpPr>
-          <p:cNvPr id="3" name="text-n5kf9o-2">
+          <p:cNvPr id="3" name="text-dflj47-2">
             <a:extLst xmlns:a="http://schemas.openxmlformats.org/drawingml/2006/main">
               <a:ext uri="{FF2B5EF4-FFF2-40B4-BE49-F238E27FC236}">
-                <a16:creationId xmlns:a16="http://schemas.microsoft.com/office/drawing/2014/main" id="{09C977B1-DB15-4D55-A283-9BCD44054F27}"/>
+                <a16:creationId xmlns:a16="http://schemas.microsoft.com/office/drawing/2014/main" id="{2EFA3DDD-CE45-4E81-8B7A-B15C7D4BCE49}"/>
               </a:ext>
             </a:extLst>
           </p:cNvPr>
@@ -9477,10 +9477,10 @@
       </p:sp>
       <p:sp>
         <p:nvSpPr>
-          <p:cNvPr id="4" name="text-n5kf9o-3">
+          <p:cNvPr id="4" name="text-dflj47-3">
             <a:extLst xmlns:a="http://schemas.openxmlformats.org/drawingml/2006/main">
               <a:ext uri="{FF2B5EF4-FFF2-40B4-BE49-F238E27FC236}">
-                <a16:creationId xmlns:a16="http://schemas.microsoft.com/office/drawing/2014/main" id="{944C610D-7C14-402F-91AA-E20020202561}"/>
+                <a16:creationId xmlns:a16="http://schemas.microsoft.com/office/drawing/2014/main" id="{5F3E6FEE-8FD4-4B94-9E9A-04F51241CAF5}"/>
               </a:ext>
             </a:extLst>
           </p:cNvPr>
@@ -9545,10 +9545,10 @@
       </p:sp>
       <p:sp>
         <p:nvSpPr>
-          <p:cNvPr id="5" name="text-n5kf9o-4">
+          <p:cNvPr id="5" name="text-dflj47-4">
             <a:extLst xmlns:a="http://schemas.openxmlformats.org/drawingml/2006/main">
               <a:ext uri="{FF2B5EF4-FFF2-40B4-BE49-F238E27FC236}">
-                <a16:creationId xmlns:a16="http://schemas.microsoft.com/office/drawing/2014/main" id="{4D011FA1-AFF7-47D0-B0C2-E210CC75108E}"/>
+                <a16:creationId xmlns:a16="http://schemas.microsoft.com/office/drawing/2014/main" id="{5F42B706-F28F-41B8-954A-D64E7C03B382}"/>
               </a:ext>
             </a:extLst>
           </p:cNvPr>
@@ -9613,10 +9613,10 @@
       </p:sp>
       <p:sp>
         <p:nvSpPr>
-          <p:cNvPr id="6" name="text-n5kf9o-5">
+          <p:cNvPr id="6" name="text-dflj47-5">
             <a:extLst xmlns:a="http://schemas.openxmlformats.org/drawingml/2006/main">
               <a:ext uri="{FF2B5EF4-FFF2-40B4-BE49-F238E27FC236}">
-                <a16:creationId xmlns:a16="http://schemas.microsoft.com/office/drawing/2014/main" id="{7B62E04E-E72C-4551-A328-929E4B9C6CD7}"/>
+                <a16:creationId xmlns:a16="http://schemas.microsoft.com/office/drawing/2014/main" id="{7B83CD5D-C7CA-4E50-BD4F-975F863D72E8}"/>
               </a:ext>
             </a:extLst>
           </p:cNvPr>
@@ -9681,10 +9681,10 @@
       </p:sp>
       <p:sp>
         <p:nvSpPr>
-          <p:cNvPr id="7" name="text-n5kf9o-6">
+          <p:cNvPr id="7" name="text-dflj47-6">
             <a:extLst xmlns:a="http://schemas.openxmlformats.org/drawingml/2006/main">
               <a:ext uri="{FF2B5EF4-FFF2-40B4-BE49-F238E27FC236}">
-                <a16:creationId xmlns:a16="http://schemas.microsoft.com/office/drawing/2014/main" id="{41E7AE10-8FA9-4B1F-B176-A40CA1615CB2}"/>
+                <a16:creationId xmlns:a16="http://schemas.microsoft.com/office/drawing/2014/main" id="{1C68296A-3F7F-4274-B915-2BFC46EB1FB7}"/>
               </a:ext>
             </a:extLst>
           </p:cNvPr>
@@ -9749,10 +9749,10 @@
       </p:sp>
       <p:sp>
         <p:nvSpPr>
-          <p:cNvPr id="8" name="text-n5kf9o-7">
+          <p:cNvPr id="8" name="text-dflj47-7">
             <a:extLst xmlns:a="http://schemas.openxmlformats.org/drawingml/2006/main">
               <a:ext uri="{FF2B5EF4-FFF2-40B4-BE49-F238E27FC236}">
-                <a16:creationId xmlns:a16="http://schemas.microsoft.com/office/drawing/2014/main" id="{E204D956-B369-47DB-B2A1-E61169E54515}"/>
+                <a16:creationId xmlns:a16="http://schemas.microsoft.com/office/drawing/2014/main" id="{3638D2BA-510E-4EC0-BAC2-28E1FA4F1C58}"/>
               </a:ext>
             </a:extLst>
           </p:cNvPr>
@@ -9817,10 +9817,10 @@
       </p:sp>
       <p:sp>
         <p:nvSpPr>
-          <p:cNvPr id="9" name="text-n5kf9o-8">
+          <p:cNvPr id="9" name="text-dflj47-8">
             <a:extLst xmlns:a="http://schemas.openxmlformats.org/drawingml/2006/main">
               <a:ext uri="{FF2B5EF4-FFF2-40B4-BE49-F238E27FC236}">
-                <a16:creationId xmlns:a16="http://schemas.microsoft.com/office/drawing/2014/main" id="{86968455-A2B8-4D15-9C65-F298EC2FDA01}"/>
+                <a16:creationId xmlns:a16="http://schemas.microsoft.com/office/drawing/2014/main" id="{3212FE00-8533-47E0-A700-50965D06D8D8}"/>
               </a:ext>
             </a:extLst>
           </p:cNvPr>
@@ -9885,10 +9885,10 @@
       </p:sp>
       <p:sp>
         <p:nvSpPr>
-          <p:cNvPr id="10" name="text-n5kf9o-9">
+          <p:cNvPr id="10" name="text-dflj47-9">
             <a:extLst xmlns:a="http://schemas.openxmlformats.org/drawingml/2006/main">
               <a:ext uri="{FF2B5EF4-FFF2-40B4-BE49-F238E27FC236}">
-                <a16:creationId xmlns:a16="http://schemas.microsoft.com/office/drawing/2014/main" id="{0B13BD98-6553-4A3C-ADEF-33B942D23A12}"/>
+                <a16:creationId xmlns:a16="http://schemas.microsoft.com/office/drawing/2014/main" id="{C7C5B69A-90AE-462D-900C-32F053D10649}"/>
               </a:ext>
             </a:extLst>
           </p:cNvPr>
@@ -9953,10 +9953,10 @@
       </p:sp>
       <p:sp>
         <p:nvSpPr>
-          <p:cNvPr id="11" name="text-n5kf9o-10">
+          <p:cNvPr id="11" name="text-dflj47-10">
             <a:extLst xmlns:a="http://schemas.openxmlformats.org/drawingml/2006/main">
               <a:ext uri="{FF2B5EF4-FFF2-40B4-BE49-F238E27FC236}">
-                <a16:creationId xmlns:a16="http://schemas.microsoft.com/office/drawing/2014/main" id="{F2D4FABC-AAAB-4234-BA8F-EE735803406A}"/>
+                <a16:creationId xmlns:a16="http://schemas.microsoft.com/office/drawing/2014/main" id="{96BDF54C-FC73-4837-8FF6-EB43A1970CAB}"/>
               </a:ext>
             </a:extLst>
           </p:cNvPr>
@@ -10021,10 +10021,10 @@
       </p:sp>
       <p:sp>
         <p:nvSpPr>
-          <p:cNvPr id="12" name="text-n5kf9o-11">
+          <p:cNvPr id="12" name="text-dflj47-11">
             <a:extLst xmlns:a="http://schemas.openxmlformats.org/drawingml/2006/main">
               <a:ext uri="{FF2B5EF4-FFF2-40B4-BE49-F238E27FC236}">
-                <a16:creationId xmlns:a16="http://schemas.microsoft.com/office/drawing/2014/main" id="{F3FD7911-160E-4B0F-8219-9E3D205E395F}"/>
+                <a16:creationId xmlns:a16="http://schemas.microsoft.com/office/drawing/2014/main" id="{9D414BE0-0F48-4993-830A-C3E0DBB61AE3}"/>
               </a:ext>
             </a:extLst>
           </p:cNvPr>
@@ -10089,10 +10089,10 @@
       </p:sp>
       <p:sp>
         <p:nvSpPr>
-          <p:cNvPr id="13" name="text-n5kf9o-12">
+          <p:cNvPr id="13" name="text-dflj47-12">
             <a:extLst xmlns:a="http://schemas.openxmlformats.org/drawingml/2006/main">
               <a:ext uri="{FF2B5EF4-FFF2-40B4-BE49-F238E27FC236}">
-                <a16:creationId xmlns:a16="http://schemas.microsoft.com/office/drawing/2014/main" id="{3963A9E2-97E4-4FEE-95D3-D664F53CAD0C}"/>
+                <a16:creationId xmlns:a16="http://schemas.microsoft.com/office/drawing/2014/main" id="{7B9440B3-F539-4FF5-934A-381490EBCAD6}"/>
               </a:ext>
             </a:extLst>
           </p:cNvPr>
@@ -10157,10 +10157,10 @@
       </p:sp>
       <p:sp>
         <p:nvSpPr>
-          <p:cNvPr id="14" name="text-n5kf9o-13">
+          <p:cNvPr id="14" name="text-dflj47-13">
             <a:extLst xmlns:a="http://schemas.openxmlformats.org/drawingml/2006/main">
               <a:ext uri="{FF2B5EF4-FFF2-40B4-BE49-F238E27FC236}">
-                <a16:creationId xmlns:a16="http://schemas.microsoft.com/office/drawing/2014/main" id="{A92F9FAA-F5D6-427E-A82C-408A7D0509B5}"/>
+                <a16:creationId xmlns:a16="http://schemas.microsoft.com/office/drawing/2014/main" id="{E9AF34B8-59DD-4F9D-BBA8-FBA61042E90B}"/>
               </a:ext>
             </a:extLst>
           </p:cNvPr>
@@ -10225,10 +10225,10 @@
       </p:sp>
       <p:sp>
         <p:nvSpPr>
-          <p:cNvPr id="15" name="text-n5kf9o-14">
+          <p:cNvPr id="15" name="text-dflj47-14">
             <a:extLst xmlns:a="http://schemas.openxmlformats.org/drawingml/2006/main">
               <a:ext uri="{FF2B5EF4-FFF2-40B4-BE49-F238E27FC236}">
-                <a16:creationId xmlns:a16="http://schemas.microsoft.com/office/drawing/2014/main" id="{5D74B1DD-0B3D-4949-AA4D-8EAFAADFA6D8}"/>
+                <a16:creationId xmlns:a16="http://schemas.microsoft.com/office/drawing/2014/main" id="{3BD1D3D6-1D07-4CA8-A553-7A2F64A86EFC}"/>
               </a:ext>
             </a:extLst>
           </p:cNvPr>
@@ -10293,10 +10293,10 @@
       </p:sp>
       <p:sp>
         <p:nvSpPr>
-          <p:cNvPr id="16" name="text-n5kf9o-15">
+          <p:cNvPr id="16" name="text-dflj47-15">
             <a:extLst xmlns:a="http://schemas.openxmlformats.org/drawingml/2006/main">
               <a:ext uri="{FF2B5EF4-FFF2-40B4-BE49-F238E27FC236}">
-                <a16:creationId xmlns:a16="http://schemas.microsoft.com/office/drawing/2014/main" id="{DAE914C5-B405-464E-91F1-8EB22E80EF1B}"/>
+                <a16:creationId xmlns:a16="http://schemas.microsoft.com/office/drawing/2014/main" id="{4E0BA328-2946-41F7-97BF-C537DEA04616}"/>
               </a:ext>
             </a:extLst>
           </p:cNvPr>
@@ -10361,10 +10361,10 @@
       </p:sp>
       <p:sp>
         <p:nvSpPr>
-          <p:cNvPr id="17" name="text-n5kf9o-16">
+          <p:cNvPr id="17" name="text-dflj47-16">
             <a:extLst xmlns:a="http://schemas.openxmlformats.org/drawingml/2006/main">
               <a:ext uri="{FF2B5EF4-FFF2-40B4-BE49-F238E27FC236}">
-                <a16:creationId xmlns:a16="http://schemas.microsoft.com/office/drawing/2014/main" id="{36DA59D3-20AF-4FDC-957B-542C064B41E8}"/>
+                <a16:creationId xmlns:a16="http://schemas.microsoft.com/office/drawing/2014/main" id="{A1359122-524A-4D0F-A7D8-DE5170936163}"/>
               </a:ext>
             </a:extLst>
           </p:cNvPr>
@@ -10429,10 +10429,10 @@
       </p:sp>
       <p:sp>
         <p:nvSpPr>
-          <p:cNvPr id="18" name="text-n5kf9o-17">
+          <p:cNvPr id="18" name="text-dflj47-17">
             <a:extLst xmlns:a="http://schemas.openxmlformats.org/drawingml/2006/main">
               <a:ext uri="{FF2B5EF4-FFF2-40B4-BE49-F238E27FC236}">
-                <a16:creationId xmlns:a16="http://schemas.microsoft.com/office/drawing/2014/main" id="{06EA2DB0-A516-42EE-B338-DF6372FF593A}"/>
+                <a16:creationId xmlns:a16="http://schemas.microsoft.com/office/drawing/2014/main" id="{FB59C669-B07C-4AF7-8173-D9DECC1FE86F}"/>
               </a:ext>
             </a:extLst>
           </p:cNvPr>
@@ -10497,10 +10497,10 @@
       </p:sp>
       <p:sp>
         <p:nvSpPr>
-          <p:cNvPr id="19" name="text-n5kf9o-18">
+          <p:cNvPr id="19" name="text-dflj47-18">
             <a:extLst xmlns:a="http://schemas.openxmlformats.org/drawingml/2006/main">
               <a:ext uri="{FF2B5EF4-FFF2-40B4-BE49-F238E27FC236}">
-                <a16:creationId xmlns:a16="http://schemas.microsoft.com/office/drawing/2014/main" id="{EFD1A2A6-B2EA-43E9-AFE1-CC7F322AE16F}"/>
+                <a16:creationId xmlns:a16="http://schemas.microsoft.com/office/drawing/2014/main" id="{106A5594-257D-44D2-A830-E9BB60289FF2}"/>
               </a:ext>
             </a:extLst>
           </p:cNvPr>
@@ -10566,7 +10566,7 @@
     </p:spTree>
     <p:extLst>
       <p:ext uri="{BB962C8B-B14F-4D97-AF65-F5344CB8AC3E}">
-        <p14:creationId xmlns:p14="http://schemas.microsoft.com/office/powerpoint/2010/main" val="418492511"/>
+        <p14:creationId xmlns:p14="http://schemas.microsoft.com/office/powerpoint/2010/main" val="1029704568"/>
       </p:ext>
     </p:extLst>
   </p:cSld>
@@ -10594,10 +10594,10 @@
       </p:grpSpPr>
       <p:sp>
         <p:nvSpPr>
-          <p:cNvPr id="7" name="text-x346id-0">
+          <p:cNvPr id="7" name="text-35mw1a-0">
             <a:extLst xmlns:a="http://schemas.openxmlformats.org/drawingml/2006/main">
               <a:ext uri="{FF2B5EF4-FFF2-40B4-BE49-F238E27FC236}">
-                <a16:creationId xmlns:a16="http://schemas.microsoft.com/office/drawing/2014/main" id="{1CF6B9F1-B895-4CA8-8F57-45CAA0AAE9F8}"/>
+                <a16:creationId xmlns:a16="http://schemas.microsoft.com/office/drawing/2014/main" id="{7D066E24-F035-4338-8394-3A6149573F21}"/>
               </a:ext>
             </a:extLst>
           </p:cNvPr>
@@ -10662,10 +10662,10 @@
       </p:sp>
       <p:sp>
         <p:nvSpPr>
-          <p:cNvPr id="2" name="text-x346id-1">
+          <p:cNvPr id="2" name="text-35mw1a-1">
             <a:extLst xmlns:a="http://schemas.openxmlformats.org/drawingml/2006/main">
               <a:ext uri="{FF2B5EF4-FFF2-40B4-BE49-F238E27FC236}">
-                <a16:creationId xmlns:a16="http://schemas.microsoft.com/office/drawing/2014/main" id="{94E231C0-6993-4AD7-9A50-6EB15EE3251F}"/>
+                <a16:creationId xmlns:a16="http://schemas.microsoft.com/office/drawing/2014/main" id="{6E055178-A224-466E-8AC8-F28418409C96}"/>
               </a:ext>
             </a:extLst>
           </p:cNvPr>
@@ -10730,10 +10730,10 @@
       </p:sp>
       <p:sp>
         <p:nvSpPr>
-          <p:cNvPr id="3" name="text-x346id-2">
+          <p:cNvPr id="3" name="text-35mw1a-2">
             <a:extLst xmlns:a="http://schemas.openxmlformats.org/drawingml/2006/main">
               <a:ext uri="{FF2B5EF4-FFF2-40B4-BE49-F238E27FC236}">
-                <a16:creationId xmlns:a16="http://schemas.microsoft.com/office/drawing/2014/main" id="{F0F32A1D-D7D3-460C-BE6E-DE1C1E138C2B}"/>
+                <a16:creationId xmlns:a16="http://schemas.microsoft.com/office/drawing/2014/main" id="{FC0F5C60-7670-4461-A6E3-28F1E6BCCCA7}"/>
               </a:ext>
             </a:extLst>
           </p:cNvPr>
@@ -10798,10 +10798,10 @@
       </p:sp>
       <p:sp>
         <p:nvSpPr>
-          <p:cNvPr id="4" name="text-x346id-3">
+          <p:cNvPr id="4" name="text-35mw1a-3">
             <a:extLst xmlns:a="http://schemas.openxmlformats.org/drawingml/2006/main">
               <a:ext uri="{FF2B5EF4-FFF2-40B4-BE49-F238E27FC236}">
-                <a16:creationId xmlns:a16="http://schemas.microsoft.com/office/drawing/2014/main" id="{9620F1CE-1146-4B2F-A5C8-85F1ABE462B2}"/>
+                <a16:creationId xmlns:a16="http://schemas.microsoft.com/office/drawing/2014/main" id="{BA8CB793-BA59-43AB-9F0C-D023005ECD4D}"/>
               </a:ext>
             </a:extLst>
           </p:cNvPr>
@@ -10869,7 +10869,7 @@
           <p:cNvPr id="5" name="">
             <a:extLst xmlns:a="http://schemas.openxmlformats.org/drawingml/2006/main">
               <a:ext uri="{FF2B5EF4-FFF2-40B4-BE49-F238E27FC236}">
-                <a16:creationId xmlns:a16="http://schemas.microsoft.com/office/drawing/2014/main" id="{29DFED71-21C7-409B-9450-EB2CAE18618B}"/>
+                <a16:creationId xmlns:a16="http://schemas.microsoft.com/office/drawing/2014/main" id="{C1FD78A6-D9D7-4A60-A439-9C45386A894B}"/>
               </a:ext>
             </a:extLst>
           </p:cNvPr>
@@ -11867,10 +11867,10 @@
       </p:graphicFrame>
       <p:sp>
         <p:nvSpPr>
-          <p:cNvPr id="6" name="text-x346id-4">
+          <p:cNvPr id="6" name="text-35mw1a-4">
             <a:extLst xmlns:a="http://schemas.openxmlformats.org/drawingml/2006/main">
               <a:ext uri="{FF2B5EF4-FFF2-40B4-BE49-F238E27FC236}">
-                <a16:creationId xmlns:a16="http://schemas.microsoft.com/office/drawing/2014/main" id="{40070CCD-40DE-41F6-982D-A90AAD642800}"/>
+                <a16:creationId xmlns:a16="http://schemas.microsoft.com/office/drawing/2014/main" id="{43AD59EE-5EEC-4F29-9714-6731335BF590}"/>
               </a:ext>
             </a:extLst>
           </p:cNvPr>
@@ -11936,7 +11936,7 @@
     </p:spTree>
     <p:extLst>
       <p:ext uri="{BB962C8B-B14F-4D97-AF65-F5344CB8AC3E}">
-        <p14:creationId xmlns:p14="http://schemas.microsoft.com/office/powerpoint/2010/main" val="856054883"/>
+        <p14:creationId xmlns:p14="http://schemas.microsoft.com/office/powerpoint/2010/main" val="58262551"/>
       </p:ext>
     </p:extLst>
   </p:cSld>
@@ -11964,10 +11964,10 @@
       </p:grpSpPr>
       <p:sp>
         <p:nvSpPr>
-          <p:cNvPr id="7" name="text-5io4bs-0">
+          <p:cNvPr id="7" name="text-jse2qn-0">
             <a:extLst xmlns:a="http://schemas.openxmlformats.org/drawingml/2006/main">
               <a:ext uri="{FF2B5EF4-FFF2-40B4-BE49-F238E27FC236}">
-                <a16:creationId xmlns:a16="http://schemas.microsoft.com/office/drawing/2014/main" id="{257FBD40-104F-4A4D-9226-100421BE263A}"/>
+                <a16:creationId xmlns:a16="http://schemas.microsoft.com/office/drawing/2014/main" id="{DCFB55C2-63EB-41B2-8A95-77541390DDEC}"/>
               </a:ext>
             </a:extLst>
           </p:cNvPr>
@@ -12032,10 +12032,10 @@
       </p:sp>
       <p:sp>
         <p:nvSpPr>
-          <p:cNvPr id="2" name="text-5io4bs-1">
+          <p:cNvPr id="2" name="text-jse2qn-1">
             <a:extLst xmlns:a="http://schemas.openxmlformats.org/drawingml/2006/main">
               <a:ext uri="{FF2B5EF4-FFF2-40B4-BE49-F238E27FC236}">
-                <a16:creationId xmlns:a16="http://schemas.microsoft.com/office/drawing/2014/main" id="{E0D87EDB-2689-4CF9-B982-3546AFD94922}"/>
+                <a16:creationId xmlns:a16="http://schemas.microsoft.com/office/drawing/2014/main" id="{AFA3F256-928B-4F4A-92AF-C8A496A6BEFC}"/>
               </a:ext>
             </a:extLst>
           </p:cNvPr>
@@ -12100,10 +12100,10 @@
       </p:sp>
       <p:sp>
         <p:nvSpPr>
-          <p:cNvPr id="3" name="text-5io4bs-2">
+          <p:cNvPr id="3" name="text-jse2qn-2">
             <a:extLst xmlns:a="http://schemas.openxmlformats.org/drawingml/2006/main">
               <a:ext uri="{FF2B5EF4-FFF2-40B4-BE49-F238E27FC236}">
-                <a16:creationId xmlns:a16="http://schemas.microsoft.com/office/drawing/2014/main" id="{651F8A74-9AA4-4EBB-92E8-93979CF393C2}"/>
+                <a16:creationId xmlns:a16="http://schemas.microsoft.com/office/drawing/2014/main" id="{C9D0824C-B028-4195-8D5B-A7DB59AEC516}"/>
               </a:ext>
             </a:extLst>
           </p:cNvPr>
@@ -12168,10 +12168,10 @@
       </p:sp>
       <p:sp>
         <p:nvSpPr>
-          <p:cNvPr id="4" name="text-5io4bs-3">
+          <p:cNvPr id="4" name="text-jse2qn-3">
             <a:extLst xmlns:a="http://schemas.openxmlformats.org/drawingml/2006/main">
               <a:ext uri="{FF2B5EF4-FFF2-40B4-BE49-F238E27FC236}">
-                <a16:creationId xmlns:a16="http://schemas.microsoft.com/office/drawing/2014/main" id="{B9F477A2-44D1-48BF-A898-8537A2AF87A7}"/>
+                <a16:creationId xmlns:a16="http://schemas.microsoft.com/office/drawing/2014/main" id="{5F1512E0-9B70-4ABE-847A-7267B0E8DC61}"/>
               </a:ext>
             </a:extLst>
           </p:cNvPr>
@@ -12239,7 +12239,7 @@
           <p:cNvPr id="5" name="">
             <a:extLst xmlns:a="http://schemas.openxmlformats.org/drawingml/2006/main">
               <a:ext uri="{FF2B5EF4-FFF2-40B4-BE49-F238E27FC236}">
-                <a16:creationId xmlns:a16="http://schemas.microsoft.com/office/drawing/2014/main" id="{EB24E52D-28B5-4BC2-A246-4EFB4EA2BF98}"/>
+                <a16:creationId xmlns:a16="http://schemas.microsoft.com/office/drawing/2014/main" id="{3D20C360-CE10-4DE2-84A2-C04AFD26A427}"/>
               </a:ext>
             </a:extLst>
           </p:cNvPr>
@@ -12249,7 +12249,7 @@
           <p:nvPr/>
         </p:nvPicPr>
         <p:blipFill>
-          <a:blip xmlns:r="http://schemas.openxmlformats.org/officeDocument/2006/relationships" xmlns:a="http://schemas.openxmlformats.org/drawingml/2006/main" r:embed="R0ae5fa5e15304d81"/>
+          <a:blip xmlns:r="http://schemas.openxmlformats.org/officeDocument/2006/relationships" xmlns:a="http://schemas.openxmlformats.org/drawingml/2006/main" r:embed="Rf96d900930f642bd"/>
           <a:srcRect xmlns:a="http://schemas.openxmlformats.org/drawingml/2006/main" l="1563" t="34722" r="18750" b="13611"/>
           <a:stretch xmlns:a="http://schemas.openxmlformats.org/drawingml/2006/main"/>
         </p:blipFill>
@@ -12265,10 +12265,10 @@
       </p:pic>
       <p:sp>
         <p:nvSpPr>
-          <p:cNvPr id="6" name="text-5io4bs-4">
+          <p:cNvPr id="6" name="text-jse2qn-4">
             <a:extLst xmlns:a="http://schemas.openxmlformats.org/drawingml/2006/main">
               <a:ext uri="{FF2B5EF4-FFF2-40B4-BE49-F238E27FC236}">
-                <a16:creationId xmlns:a16="http://schemas.microsoft.com/office/drawing/2014/main" id="{FF867FA2-2639-4E2B-BB05-1C1F44DB446D}"/>
+                <a16:creationId xmlns:a16="http://schemas.microsoft.com/office/drawing/2014/main" id="{63702310-BF5B-4CE2-9CA2-265A024E13B9}"/>
               </a:ext>
             </a:extLst>
           </p:cNvPr>
@@ -12357,7 +12357,7 @@
     </p:spTree>
     <p:extLst>
       <p:ext uri="{BB962C8B-B14F-4D97-AF65-F5344CB8AC3E}">
-        <p14:creationId xmlns:p14="http://schemas.microsoft.com/office/powerpoint/2010/main" val="564050964"/>
+        <p14:creationId xmlns:p14="http://schemas.microsoft.com/office/powerpoint/2010/main" val="1807312810"/>
       </p:ext>
     </p:extLst>
   </p:cSld>
@@ -12385,10 +12385,10 @@
       </p:grpSpPr>
       <p:sp>
         <p:nvSpPr>
-          <p:cNvPr id="7" name="text-5jbjau-0">
+          <p:cNvPr id="7" name="text-hobue5-0">
             <a:extLst xmlns:a="http://schemas.openxmlformats.org/drawingml/2006/main">
               <a:ext uri="{FF2B5EF4-FFF2-40B4-BE49-F238E27FC236}">
-                <a16:creationId xmlns:a16="http://schemas.microsoft.com/office/drawing/2014/main" id="{768F83D5-0F14-4A9E-AF76-C2155699CF44}"/>
+                <a16:creationId xmlns:a16="http://schemas.microsoft.com/office/drawing/2014/main" id="{018902C6-ED05-424C-8D24-4D8D6410404A}"/>
               </a:ext>
             </a:extLst>
           </p:cNvPr>
@@ -12453,10 +12453,10 @@
       </p:sp>
       <p:sp>
         <p:nvSpPr>
-          <p:cNvPr id="2" name="text-5jbjau-1">
+          <p:cNvPr id="2" name="text-hobue5-1">
             <a:extLst xmlns:a="http://schemas.openxmlformats.org/drawingml/2006/main">
               <a:ext uri="{FF2B5EF4-FFF2-40B4-BE49-F238E27FC236}">
-                <a16:creationId xmlns:a16="http://schemas.microsoft.com/office/drawing/2014/main" id="{41351365-B0E6-4179-B302-892BC52BDF8C}"/>
+                <a16:creationId xmlns:a16="http://schemas.microsoft.com/office/drawing/2014/main" id="{AB0AAD90-833C-402D-B341-1870E6B0C4A6}"/>
               </a:ext>
             </a:extLst>
           </p:cNvPr>
@@ -12521,10 +12521,10 @@
       </p:sp>
       <p:sp>
         <p:nvSpPr>
-          <p:cNvPr id="3" name="text-5jbjau-2">
+          <p:cNvPr id="3" name="text-hobue5-2">
             <a:extLst xmlns:a="http://schemas.openxmlformats.org/drawingml/2006/main">
               <a:ext uri="{FF2B5EF4-FFF2-40B4-BE49-F238E27FC236}">
-                <a16:creationId xmlns:a16="http://schemas.microsoft.com/office/drawing/2014/main" id="{EFA5D16F-239E-49AB-81C5-5401131FBB8F}"/>
+                <a16:creationId xmlns:a16="http://schemas.microsoft.com/office/drawing/2014/main" id="{439EF22B-A65F-4AE2-95BE-CE661FF5C31F}"/>
               </a:ext>
             </a:extLst>
           </p:cNvPr>
@@ -12589,10 +12589,10 @@
       </p:sp>
       <p:sp>
         <p:nvSpPr>
-          <p:cNvPr id="4" name="text-5jbjau-3">
+          <p:cNvPr id="4" name="text-hobue5-3">
             <a:extLst xmlns:a="http://schemas.openxmlformats.org/drawingml/2006/main">
               <a:ext uri="{FF2B5EF4-FFF2-40B4-BE49-F238E27FC236}">
-                <a16:creationId xmlns:a16="http://schemas.microsoft.com/office/drawing/2014/main" id="{215D76A0-BD20-433F-8244-9ACC3FD45D6F}"/>
+                <a16:creationId xmlns:a16="http://schemas.microsoft.com/office/drawing/2014/main" id="{6116DC87-FBCE-4DC3-9FAC-F6407918C195}"/>
               </a:ext>
             </a:extLst>
           </p:cNvPr>
@@ -12660,7 +12660,7 @@
           <p:cNvPr id="5" name="">
             <a:extLst xmlns:a="http://schemas.openxmlformats.org/drawingml/2006/main">
               <a:ext uri="{FF2B5EF4-FFF2-40B4-BE49-F238E27FC236}">
-                <a16:creationId xmlns:a16="http://schemas.microsoft.com/office/drawing/2014/main" id="{F0A7A14C-D8F4-451D-A6DB-A7D00D414B69}"/>
+                <a16:creationId xmlns:a16="http://schemas.microsoft.com/office/drawing/2014/main" id="{3170EAAD-7923-414E-8696-B9B53C642D28}"/>
               </a:ext>
             </a:extLst>
           </p:cNvPr>
@@ -12670,7 +12670,7 @@
           <p:nvPr/>
         </p:nvPicPr>
         <p:blipFill>
-          <a:blip xmlns:r="http://schemas.openxmlformats.org/officeDocument/2006/relationships" xmlns:a="http://schemas.openxmlformats.org/drawingml/2006/main" r:embed="R15e31e485f8e4d17"/>
+          <a:blip xmlns:r="http://schemas.openxmlformats.org/officeDocument/2006/relationships" xmlns:a="http://schemas.openxmlformats.org/drawingml/2006/main" r:embed="R29ce4f58326f4cc6"/>
           <a:srcRect xmlns:a="http://schemas.openxmlformats.org/drawingml/2006/main" l="1953" t="22917" r="2734" b="20417"/>
           <a:stretch xmlns:a="http://schemas.openxmlformats.org/drawingml/2006/main"/>
         </p:blipFill>
@@ -12686,10 +12686,10 @@
       </p:pic>
       <p:sp>
         <p:nvSpPr>
-          <p:cNvPr id="6" name="text-5jbjau-4">
+          <p:cNvPr id="6" name="text-hobue5-4">
             <a:extLst xmlns:a="http://schemas.openxmlformats.org/drawingml/2006/main">
               <a:ext uri="{FF2B5EF4-FFF2-40B4-BE49-F238E27FC236}">
-                <a16:creationId xmlns:a16="http://schemas.microsoft.com/office/drawing/2014/main" id="{AA5DD412-C2D2-4E69-ADCA-49D81F890915}"/>
+                <a16:creationId xmlns:a16="http://schemas.microsoft.com/office/drawing/2014/main" id="{E3343B95-5CAA-4E93-A523-EAE347FE940C}"/>
               </a:ext>
             </a:extLst>
           </p:cNvPr>
@@ -12747,7 +12747,7 @@
                 <a:ea typeface="Arial"/>
                 <a:cs typeface="Arial"/>
               </a:rPr>
-              <a:t>B now has 500 units reserved. Prepared and non-campaign stock stays protected.</a:t>
+              <a:t>B now has 500 units reserved. Prepared and outside reservations stay protected.</a:t>
             </a:r>
           </a:p>
         </p:txBody>
@@ -12755,7 +12755,7 @@
     </p:spTree>
     <p:extLst>
       <p:ext uri="{BB962C8B-B14F-4D97-AF65-F5344CB8AC3E}">
-        <p14:creationId xmlns:p14="http://schemas.microsoft.com/office/powerpoint/2010/main" val="2056225231"/>
+        <p14:creationId xmlns:p14="http://schemas.microsoft.com/office/powerpoint/2010/main" val="201253574"/>
       </p:ext>
     </p:extLst>
   </p:cSld>
@@ -12783,10 +12783,10 @@
       </p:grpSpPr>
       <p:sp>
         <p:nvSpPr>
-          <p:cNvPr id="7" name="text-eqj12e-0">
+          <p:cNvPr id="7" name="text-x5wgmk-0">
             <a:extLst xmlns:a="http://schemas.openxmlformats.org/drawingml/2006/main">
               <a:ext uri="{FF2B5EF4-FFF2-40B4-BE49-F238E27FC236}">
-                <a16:creationId xmlns:a16="http://schemas.microsoft.com/office/drawing/2014/main" id="{EAFB49D7-7D71-4CF7-A928-67E2EF61EC71}"/>
+                <a16:creationId xmlns:a16="http://schemas.microsoft.com/office/drawing/2014/main" id="{D23478E8-CDE9-436B-A809-2FA68C247CA5}"/>
               </a:ext>
             </a:extLst>
           </p:cNvPr>
@@ -12851,10 +12851,10 @@
       </p:sp>
       <p:sp>
         <p:nvSpPr>
-          <p:cNvPr id="2" name="text-eqj12e-1">
+          <p:cNvPr id="2" name="text-x5wgmk-1">
             <a:extLst xmlns:a="http://schemas.openxmlformats.org/drawingml/2006/main">
               <a:ext uri="{FF2B5EF4-FFF2-40B4-BE49-F238E27FC236}">
-                <a16:creationId xmlns:a16="http://schemas.microsoft.com/office/drawing/2014/main" id="{EFDBD011-9B19-4660-A1D4-D57B0D6F6A45}"/>
+                <a16:creationId xmlns:a16="http://schemas.microsoft.com/office/drawing/2014/main" id="{FE06D6E5-7F19-4E6B-BF17-2F7BBB264E74}"/>
               </a:ext>
             </a:extLst>
           </p:cNvPr>
@@ -12919,10 +12919,10 @@
       </p:sp>
       <p:sp>
         <p:nvSpPr>
-          <p:cNvPr id="3" name="text-eqj12e-2">
+          <p:cNvPr id="3" name="text-x5wgmk-2">
             <a:extLst xmlns:a="http://schemas.openxmlformats.org/drawingml/2006/main">
               <a:ext uri="{FF2B5EF4-FFF2-40B4-BE49-F238E27FC236}">
-                <a16:creationId xmlns:a16="http://schemas.microsoft.com/office/drawing/2014/main" id="{BDD93F58-D8B3-4FF3-B4BC-48448533B30D}"/>
+                <a16:creationId xmlns:a16="http://schemas.microsoft.com/office/drawing/2014/main" id="{3F758316-1C73-46B4-8413-E963377FA278}"/>
               </a:ext>
             </a:extLst>
           </p:cNvPr>
@@ -12987,10 +12987,10 @@
       </p:sp>
       <p:sp>
         <p:nvSpPr>
-          <p:cNvPr id="4" name="text-eqj12e-3">
+          <p:cNvPr id="4" name="text-x5wgmk-3">
             <a:extLst xmlns:a="http://schemas.openxmlformats.org/drawingml/2006/main">
               <a:ext uri="{FF2B5EF4-FFF2-40B4-BE49-F238E27FC236}">
-                <a16:creationId xmlns:a16="http://schemas.microsoft.com/office/drawing/2014/main" id="{7FD272B1-DE03-493C-9926-3B85FC7F2E5C}"/>
+                <a16:creationId xmlns:a16="http://schemas.microsoft.com/office/drawing/2014/main" id="{51FBF393-4C0B-4CB0-997C-67B656962206}"/>
               </a:ext>
             </a:extLst>
           </p:cNvPr>
@@ -13058,7 +13058,7 @@
           <p:cNvPr id="5" name="">
             <a:extLst xmlns:a="http://schemas.openxmlformats.org/drawingml/2006/main">
               <a:ext uri="{FF2B5EF4-FFF2-40B4-BE49-F238E27FC236}">
-                <a16:creationId xmlns:a16="http://schemas.microsoft.com/office/drawing/2014/main" id="{8122688D-EC7E-40EA-905C-C4FCE65117B1}"/>
+                <a16:creationId xmlns:a16="http://schemas.microsoft.com/office/drawing/2014/main" id="{B6DA37F3-4FCE-478D-85B4-3B64C4396884}"/>
               </a:ext>
             </a:extLst>
           </p:cNvPr>
@@ -13068,7 +13068,7 @@
           <p:nvPr/>
         </p:nvPicPr>
         <p:blipFill>
-          <a:blip xmlns:r="http://schemas.openxmlformats.org/officeDocument/2006/relationships" xmlns:a="http://schemas.openxmlformats.org/drawingml/2006/main" r:embed="R0fc4418f95f243e9"/>
+          <a:blip xmlns:r="http://schemas.openxmlformats.org/officeDocument/2006/relationships" xmlns:a="http://schemas.openxmlformats.org/drawingml/2006/main" r:embed="R6f11b432719745cd"/>
           <a:srcRect xmlns:a="http://schemas.openxmlformats.org/drawingml/2006/main" l="4688" t="35417" r="4688" b="22639"/>
           <a:stretch xmlns:a="http://schemas.openxmlformats.org/drawingml/2006/main"/>
         </p:blipFill>
@@ -13084,10 +13084,10 @@
       </p:pic>
       <p:sp>
         <p:nvSpPr>
-          <p:cNvPr id="6" name="text-eqj12e-4">
+          <p:cNvPr id="6" name="text-x5wgmk-4">
             <a:extLst xmlns:a="http://schemas.openxmlformats.org/drawingml/2006/main">
               <a:ext uri="{FF2B5EF4-FFF2-40B4-BE49-F238E27FC236}">
-                <a16:creationId xmlns:a16="http://schemas.microsoft.com/office/drawing/2014/main" id="{9D549AC2-58D4-4E8F-AC9E-A7EBDD11A774}"/>
+                <a16:creationId xmlns:a16="http://schemas.microsoft.com/office/drawing/2014/main" id="{ADCB4245-3D29-4580-ADF0-3F77ABF15A5B}"/>
               </a:ext>
             </a:extLst>
           </p:cNvPr>
@@ -13153,7 +13153,7 @@
     </p:spTree>
     <p:extLst>
       <p:ext uri="{BB962C8B-B14F-4D97-AF65-F5344CB8AC3E}">
-        <p14:creationId xmlns:p14="http://schemas.microsoft.com/office/powerpoint/2010/main" val="734706145"/>
+        <p14:creationId xmlns:p14="http://schemas.microsoft.com/office/powerpoint/2010/main" val="219592922"/>
       </p:ext>
     </p:extLst>
   </p:cSld>
@@ -13181,10 +13181,10 @@
       </p:grpSpPr>
       <p:sp>
         <p:nvSpPr>
-          <p:cNvPr id="11" name="text-7tv0bb-0">
+          <p:cNvPr id="11" name="text-3332e2-0">
             <a:extLst xmlns:a="http://schemas.openxmlformats.org/drawingml/2006/main">
               <a:ext uri="{FF2B5EF4-FFF2-40B4-BE49-F238E27FC236}">
-                <a16:creationId xmlns:a16="http://schemas.microsoft.com/office/drawing/2014/main" id="{00382CC8-A518-4CEB-8C4E-AF7C2343C297}"/>
+                <a16:creationId xmlns:a16="http://schemas.microsoft.com/office/drawing/2014/main" id="{A58792DE-E1BC-41B6-A361-62D6E77AFD7C}"/>
               </a:ext>
             </a:extLst>
           </p:cNvPr>
@@ -13249,10 +13249,10 @@
       </p:sp>
       <p:sp>
         <p:nvSpPr>
-          <p:cNvPr id="2" name="text-7tv0bb-1">
+          <p:cNvPr id="2" name="text-3332e2-1">
             <a:extLst xmlns:a="http://schemas.openxmlformats.org/drawingml/2006/main">
               <a:ext uri="{FF2B5EF4-FFF2-40B4-BE49-F238E27FC236}">
-                <a16:creationId xmlns:a16="http://schemas.microsoft.com/office/drawing/2014/main" id="{834CA970-7206-45BB-9293-C61FC657500F}"/>
+                <a16:creationId xmlns:a16="http://schemas.microsoft.com/office/drawing/2014/main" id="{64FECAA7-83EF-46E3-BB8E-5B7C9688974C}"/>
               </a:ext>
             </a:extLst>
           </p:cNvPr>
@@ -13317,10 +13317,10 @@
       </p:sp>
       <p:sp>
         <p:nvSpPr>
-          <p:cNvPr id="3" name="text-7tv0bb-2">
+          <p:cNvPr id="3" name="text-3332e2-2">
             <a:extLst xmlns:a="http://schemas.openxmlformats.org/drawingml/2006/main">
               <a:ext uri="{FF2B5EF4-FFF2-40B4-BE49-F238E27FC236}">
-                <a16:creationId xmlns:a16="http://schemas.microsoft.com/office/drawing/2014/main" id="{3ABD3891-3259-40F2-8193-E621DE9CB27D}"/>
+                <a16:creationId xmlns:a16="http://schemas.microsoft.com/office/drawing/2014/main" id="{69C69CBC-E9FC-4328-AB55-46C368C5E920}"/>
               </a:ext>
             </a:extLst>
           </p:cNvPr>
@@ -13385,10 +13385,10 @@
       </p:sp>
       <p:sp>
         <p:nvSpPr>
-          <p:cNvPr id="4" name="text-7tv0bb-3">
+          <p:cNvPr id="4" name="text-3332e2-3">
             <a:extLst xmlns:a="http://schemas.openxmlformats.org/drawingml/2006/main">
               <a:ext uri="{FF2B5EF4-FFF2-40B4-BE49-F238E27FC236}">
-                <a16:creationId xmlns:a16="http://schemas.microsoft.com/office/drawing/2014/main" id="{1034264B-4E02-47EE-834B-B5E5987C45C6}"/>
+                <a16:creationId xmlns:a16="http://schemas.microsoft.com/office/drawing/2014/main" id="{8FEB1DF7-0A57-44B2-82E4-1D08059DCC3F}"/>
               </a:ext>
             </a:extLst>
           </p:cNvPr>
@@ -13453,10 +13453,10 @@
       </p:sp>
       <p:sp>
         <p:nvSpPr>
-          <p:cNvPr id="5" name="text-7tv0bb-4">
+          <p:cNvPr id="5" name="text-3332e2-4">
             <a:extLst xmlns:a="http://schemas.openxmlformats.org/drawingml/2006/main">
               <a:ext uri="{FF2B5EF4-FFF2-40B4-BE49-F238E27FC236}">
-                <a16:creationId xmlns:a16="http://schemas.microsoft.com/office/drawing/2014/main" id="{318A0FDE-BF56-4B47-873F-0559F6EA3F94}"/>
+                <a16:creationId xmlns:a16="http://schemas.microsoft.com/office/drawing/2014/main" id="{282DCA74-5FF2-4AAE-8B86-61710F64DA64}"/>
               </a:ext>
             </a:extLst>
           </p:cNvPr>
@@ -13521,10 +13521,10 @@
       </p:sp>
       <p:sp>
         <p:nvSpPr>
-          <p:cNvPr id="6" name="text-7tv0bb-5">
+          <p:cNvPr id="6" name="text-3332e2-5">
             <a:extLst xmlns:a="http://schemas.openxmlformats.org/drawingml/2006/main">
               <a:ext uri="{FF2B5EF4-FFF2-40B4-BE49-F238E27FC236}">
-                <a16:creationId xmlns:a16="http://schemas.microsoft.com/office/drawing/2014/main" id="{1A29D7BA-6256-429D-BCCD-D7BA0F16DD7C}"/>
+                <a16:creationId xmlns:a16="http://schemas.microsoft.com/office/drawing/2014/main" id="{22DA1F5A-49B2-4784-9A86-90DEBBD61282}"/>
               </a:ext>
             </a:extLst>
           </p:cNvPr>
@@ -13592,7 +13592,7 @@
           <p:cNvPr id="7" name="">
             <a:extLst xmlns:a="http://schemas.openxmlformats.org/drawingml/2006/main">
               <a:ext uri="{FF2B5EF4-FFF2-40B4-BE49-F238E27FC236}">
-                <a16:creationId xmlns:a16="http://schemas.microsoft.com/office/drawing/2014/main" id="{7B66201F-F036-4716-93B5-E8D9844B420F}"/>
+                <a16:creationId xmlns:a16="http://schemas.microsoft.com/office/drawing/2014/main" id="{8B22DBC2-123B-4658-95BF-052A87D526A2}"/>
               </a:ext>
             </a:extLst>
           </p:cNvPr>
@@ -13602,7 +13602,7 @@
           <p:nvPr/>
         </p:nvPicPr>
         <p:blipFill>
-          <a:blip xmlns:r="http://schemas.openxmlformats.org/officeDocument/2006/relationships" xmlns:a="http://schemas.openxmlformats.org/drawingml/2006/main" r:embed="R199622b686544bf1"/>
+          <a:blip xmlns:r="http://schemas.openxmlformats.org/officeDocument/2006/relationships" xmlns:a="http://schemas.openxmlformats.org/drawingml/2006/main" r:embed="R7442f90ec8784eb1"/>
           <a:srcRect xmlns:a="http://schemas.openxmlformats.org/drawingml/2006/main" l="50781" t="15278" r="1563" b="33333"/>
           <a:stretch xmlns:a="http://schemas.openxmlformats.org/drawingml/2006/main"/>
         </p:blipFill>
@@ -13621,7 +13621,7 @@
           <p:cNvPr id="8" name="">
             <a:extLst xmlns:a="http://schemas.openxmlformats.org/drawingml/2006/main">
               <a:ext uri="{FF2B5EF4-FFF2-40B4-BE49-F238E27FC236}">
-                <a16:creationId xmlns:a16="http://schemas.microsoft.com/office/drawing/2014/main" id="{3A9BA1C7-AEA2-49F6-B157-9DDF26A33D23}"/>
+                <a16:creationId xmlns:a16="http://schemas.microsoft.com/office/drawing/2014/main" id="{05AB3B8C-C10D-47EA-91C4-8CC0B4AFA658}"/>
               </a:ext>
             </a:extLst>
           </p:cNvPr>
@@ -13631,7 +13631,7 @@
           <p:nvPr/>
         </p:nvPicPr>
         <p:blipFill>
-          <a:blip xmlns:r="http://schemas.openxmlformats.org/officeDocument/2006/relationships" xmlns:a="http://schemas.openxmlformats.org/drawingml/2006/main" r:embed="R7488024911474bd4"/>
+          <a:blip xmlns:r="http://schemas.openxmlformats.org/officeDocument/2006/relationships" xmlns:a="http://schemas.openxmlformats.org/drawingml/2006/main" r:embed="R51e19d87aee04092"/>
           <a:srcRect xmlns:a="http://schemas.openxmlformats.org/drawingml/2006/main" l="50781" t="15278" r="1563" b="26389"/>
           <a:stretch xmlns:a="http://schemas.openxmlformats.org/drawingml/2006/main"/>
         </p:blipFill>
@@ -13647,10 +13647,10 @@
       </p:pic>
       <p:sp>
         <p:nvSpPr>
-          <p:cNvPr id="9" name="text-7tv0bb-6">
+          <p:cNvPr id="9" name="text-3332e2-6">
             <a:extLst xmlns:a="http://schemas.openxmlformats.org/drawingml/2006/main">
               <a:ext uri="{FF2B5EF4-FFF2-40B4-BE49-F238E27FC236}">
-                <a16:creationId xmlns:a16="http://schemas.microsoft.com/office/drawing/2014/main" id="{9C017793-8591-4893-BEA1-6B881A595A9A}"/>
+                <a16:creationId xmlns:a16="http://schemas.microsoft.com/office/drawing/2014/main" id="{0FA4F8AF-9F03-4D14-AE04-88F286D4AAEA}"/>
               </a:ext>
             </a:extLst>
           </p:cNvPr>
@@ -13715,10 +13715,10 @@
       </p:sp>
       <p:sp>
         <p:nvSpPr>
-          <p:cNvPr id="10" name="text-7tv0bb-7">
+          <p:cNvPr id="10" name="text-3332e2-7">
             <a:extLst xmlns:a="http://schemas.openxmlformats.org/drawingml/2006/main">
               <a:ext uri="{FF2B5EF4-FFF2-40B4-BE49-F238E27FC236}">
-                <a16:creationId xmlns:a16="http://schemas.microsoft.com/office/drawing/2014/main" id="{6CE772BF-6DD5-4749-B7D0-C51BB3436A4C}"/>
+                <a16:creationId xmlns:a16="http://schemas.microsoft.com/office/drawing/2014/main" id="{7889D98D-B04C-4459-9471-55114973C029}"/>
               </a:ext>
             </a:extLst>
           </p:cNvPr>
@@ -13784,7 +13784,7 @@
     </p:spTree>
     <p:extLst>
       <p:ext uri="{BB962C8B-B14F-4D97-AF65-F5344CB8AC3E}">
-        <p14:creationId xmlns:p14="http://schemas.microsoft.com/office/powerpoint/2010/main" val="397410445"/>
+        <p14:creationId xmlns:p14="http://schemas.microsoft.com/office/powerpoint/2010/main" val="55831563"/>
       </p:ext>
     </p:extLst>
   </p:cSld>
@@ -13812,10 +13812,10 @@
       </p:grpSpPr>
       <p:sp>
         <p:nvSpPr>
-          <p:cNvPr id="15" name="text-2ea0nf-0">
+          <p:cNvPr id="15" name="text-cpcnzk-0">
             <a:extLst xmlns:a="http://schemas.openxmlformats.org/drawingml/2006/main">
               <a:ext uri="{FF2B5EF4-FFF2-40B4-BE49-F238E27FC236}">
-                <a16:creationId xmlns:a16="http://schemas.microsoft.com/office/drawing/2014/main" id="{F0447DF3-0ED4-4B28-A8BD-C2E005D0F993}"/>
+                <a16:creationId xmlns:a16="http://schemas.microsoft.com/office/drawing/2014/main" id="{259EB49C-42EC-417F-BBEC-D3F8FDCE5FFC}"/>
               </a:ext>
             </a:extLst>
           </p:cNvPr>
@@ -13880,10 +13880,10 @@
       </p:sp>
       <p:sp>
         <p:nvSpPr>
-          <p:cNvPr id="2" name="text-2ea0nf-1">
+          <p:cNvPr id="2" name="text-cpcnzk-1">
             <a:extLst xmlns:a="http://schemas.openxmlformats.org/drawingml/2006/main">
               <a:ext uri="{FF2B5EF4-FFF2-40B4-BE49-F238E27FC236}">
-                <a16:creationId xmlns:a16="http://schemas.microsoft.com/office/drawing/2014/main" id="{BB7593FD-C703-4057-A0E1-9B5766E844D6}"/>
+                <a16:creationId xmlns:a16="http://schemas.microsoft.com/office/drawing/2014/main" id="{0EFCFD51-C5EE-4794-B66C-603470210FB3}"/>
               </a:ext>
             </a:extLst>
           </p:cNvPr>
@@ -13948,10 +13948,10 @@
       </p:sp>
       <p:sp>
         <p:nvSpPr>
-          <p:cNvPr id="3" name="text-2ea0nf-2">
+          <p:cNvPr id="3" name="text-cpcnzk-2">
             <a:extLst xmlns:a="http://schemas.openxmlformats.org/drawingml/2006/main">
               <a:ext uri="{FF2B5EF4-FFF2-40B4-BE49-F238E27FC236}">
-                <a16:creationId xmlns:a16="http://schemas.microsoft.com/office/drawing/2014/main" id="{559EAEE7-8830-493D-82EB-70044DB10AEB}"/>
+                <a16:creationId xmlns:a16="http://schemas.microsoft.com/office/drawing/2014/main" id="{C3096D46-24F1-41D7-939A-B82935CF4E3B}"/>
               </a:ext>
             </a:extLst>
           </p:cNvPr>
@@ -14016,10 +14016,10 @@
       </p:sp>
       <p:sp>
         <p:nvSpPr>
-          <p:cNvPr id="4" name="text-2ea0nf-3">
+          <p:cNvPr id="4" name="text-cpcnzk-3">
             <a:extLst xmlns:a="http://schemas.openxmlformats.org/drawingml/2006/main">
               <a:ext uri="{FF2B5EF4-FFF2-40B4-BE49-F238E27FC236}">
-                <a16:creationId xmlns:a16="http://schemas.microsoft.com/office/drawing/2014/main" id="{75AAE8EB-B7E9-4B1D-A707-7121EBD46691}"/>
+                <a16:creationId xmlns:a16="http://schemas.microsoft.com/office/drawing/2014/main" id="{0A1FEEC4-02DC-476D-AE92-63B165DE0116}"/>
               </a:ext>
             </a:extLst>
           </p:cNvPr>
@@ -14084,10 +14084,10 @@
       </p:sp>
       <p:sp>
         <p:nvSpPr>
-          <p:cNvPr id="5" name="text-2ea0nf-4">
+          <p:cNvPr id="5" name="text-cpcnzk-4">
             <a:extLst xmlns:a="http://schemas.openxmlformats.org/drawingml/2006/main">
               <a:ext uri="{FF2B5EF4-FFF2-40B4-BE49-F238E27FC236}">
-                <a16:creationId xmlns:a16="http://schemas.microsoft.com/office/drawing/2014/main" id="{2C8D106D-3968-4A19-B207-66ADBF3AEE73}"/>
+                <a16:creationId xmlns:a16="http://schemas.microsoft.com/office/drawing/2014/main" id="{E8F717EB-C3E4-461E-86D9-10CC9CDF87D9}"/>
               </a:ext>
             </a:extLst>
           </p:cNvPr>
@@ -14152,10 +14152,10 @@
       </p:sp>
       <p:sp>
         <p:nvSpPr>
-          <p:cNvPr id="6" name="text-2ea0nf-5">
+          <p:cNvPr id="6" name="text-cpcnzk-5">
             <a:extLst xmlns:a="http://schemas.openxmlformats.org/drawingml/2006/main">
               <a:ext uri="{FF2B5EF4-FFF2-40B4-BE49-F238E27FC236}">
-                <a16:creationId xmlns:a16="http://schemas.microsoft.com/office/drawing/2014/main" id="{D3EED59A-762B-413B-A534-40FEE49A1150}"/>
+                <a16:creationId xmlns:a16="http://schemas.microsoft.com/office/drawing/2014/main" id="{59200116-B664-4190-8EE1-53BD86223B3E}"/>
               </a:ext>
             </a:extLst>
           </p:cNvPr>
@@ -14220,10 +14220,10 @@
       </p:sp>
       <p:sp>
         <p:nvSpPr>
-          <p:cNvPr id="7" name="text-2ea0nf-6">
+          <p:cNvPr id="7" name="text-cpcnzk-6">
             <a:extLst xmlns:a="http://schemas.openxmlformats.org/drawingml/2006/main">
               <a:ext uri="{FF2B5EF4-FFF2-40B4-BE49-F238E27FC236}">
-                <a16:creationId xmlns:a16="http://schemas.microsoft.com/office/drawing/2014/main" id="{362C2892-DA20-46B3-99DC-0C296BDC9871}"/>
+                <a16:creationId xmlns:a16="http://schemas.microsoft.com/office/drawing/2014/main" id="{0DCBB5CF-F163-4CDE-91D1-3C8DCEE89A82}"/>
               </a:ext>
             </a:extLst>
           </p:cNvPr>
@@ -14288,10 +14288,10 @@
       </p:sp>
       <p:sp>
         <p:nvSpPr>
-          <p:cNvPr id="8" name="text-2ea0nf-7">
+          <p:cNvPr id="8" name="text-cpcnzk-7">
             <a:extLst xmlns:a="http://schemas.openxmlformats.org/drawingml/2006/main">
               <a:ext uri="{FF2B5EF4-FFF2-40B4-BE49-F238E27FC236}">
-                <a16:creationId xmlns:a16="http://schemas.microsoft.com/office/drawing/2014/main" id="{C83CC9CA-1D2A-41B0-BE25-48E8417629BE}"/>
+                <a16:creationId xmlns:a16="http://schemas.microsoft.com/office/drawing/2014/main" id="{B64F95FC-71C8-44B5-8154-C18ECB7D30CE}"/>
               </a:ext>
             </a:extLst>
           </p:cNvPr>
@@ -14356,10 +14356,10 @@
       </p:sp>
       <p:sp>
         <p:nvSpPr>
-          <p:cNvPr id="9" name="text-2ea0nf-8">
+          <p:cNvPr id="9" name="text-cpcnzk-8">
             <a:extLst xmlns:a="http://schemas.openxmlformats.org/drawingml/2006/main">
               <a:ext uri="{FF2B5EF4-FFF2-40B4-BE49-F238E27FC236}">
-                <a16:creationId xmlns:a16="http://schemas.microsoft.com/office/drawing/2014/main" id="{3789DC9D-EDA6-496B-AC36-84392EE251E7}"/>
+                <a16:creationId xmlns:a16="http://schemas.microsoft.com/office/drawing/2014/main" id="{8F5406A2-A83F-49EF-B019-4F4D8EF426ED}"/>
               </a:ext>
             </a:extLst>
           </p:cNvPr>
@@ -14424,10 +14424,10 @@
       </p:sp>
       <p:sp>
         <p:nvSpPr>
-          <p:cNvPr id="10" name="text-2ea0nf-9">
+          <p:cNvPr id="10" name="text-cpcnzk-9">
             <a:extLst xmlns:a="http://schemas.openxmlformats.org/drawingml/2006/main">
               <a:ext uri="{FF2B5EF4-FFF2-40B4-BE49-F238E27FC236}">
-                <a16:creationId xmlns:a16="http://schemas.microsoft.com/office/drawing/2014/main" id="{CAA1302E-E3AD-4EE2-BA25-2438531823D2}"/>
+                <a16:creationId xmlns:a16="http://schemas.microsoft.com/office/drawing/2014/main" id="{5452C024-4D14-4CB6-BA1B-6B8363FF8495}"/>
               </a:ext>
             </a:extLst>
           </p:cNvPr>
@@ -14492,10 +14492,10 @@
       </p:sp>
       <p:sp>
         <p:nvSpPr>
-          <p:cNvPr id="11" name="text-2ea0nf-10">
+          <p:cNvPr id="11" name="text-cpcnzk-10">
             <a:extLst xmlns:a="http://schemas.openxmlformats.org/drawingml/2006/main">
               <a:ext uri="{FF2B5EF4-FFF2-40B4-BE49-F238E27FC236}">
-                <a16:creationId xmlns:a16="http://schemas.microsoft.com/office/drawing/2014/main" id="{83791B0A-07C8-479D-9E8C-8DC4B05D7B5E}"/>
+                <a16:creationId xmlns:a16="http://schemas.microsoft.com/office/drawing/2014/main" id="{7DF633C3-EA15-475B-B22A-77921A79CC9A}"/>
               </a:ext>
             </a:extLst>
           </p:cNvPr>
@@ -14560,10 +14560,10 @@
       </p:sp>
       <p:sp>
         <p:nvSpPr>
-          <p:cNvPr id="12" name="text-2ea0nf-11">
+          <p:cNvPr id="12" name="text-cpcnzk-11">
             <a:extLst xmlns:a="http://schemas.openxmlformats.org/drawingml/2006/main">
               <a:ext uri="{FF2B5EF4-FFF2-40B4-BE49-F238E27FC236}">
-                <a16:creationId xmlns:a16="http://schemas.microsoft.com/office/drawing/2014/main" id="{B17998BC-9589-41A7-8BE4-17413D0F3B2F}"/>
+                <a16:creationId xmlns:a16="http://schemas.microsoft.com/office/drawing/2014/main" id="{39D61798-BFAE-4CD9-ACBD-9F6AF6E97C9B}"/>
               </a:ext>
             </a:extLst>
           </p:cNvPr>
@@ -14628,10 +14628,10 @@
       </p:sp>
       <p:sp>
         <p:nvSpPr>
-          <p:cNvPr id="13" name="text-2ea0nf-12">
+          <p:cNvPr id="13" name="text-cpcnzk-12">
             <a:extLst xmlns:a="http://schemas.openxmlformats.org/drawingml/2006/main">
               <a:ext uri="{FF2B5EF4-FFF2-40B4-BE49-F238E27FC236}">
-                <a16:creationId xmlns:a16="http://schemas.microsoft.com/office/drawing/2014/main" id="{E6E243C6-4BFB-4EA3-A375-E0E951E64409}"/>
+                <a16:creationId xmlns:a16="http://schemas.microsoft.com/office/drawing/2014/main" id="{9CE2D4F4-CBD2-4465-BF07-4CD3AE672C7D}"/>
               </a:ext>
             </a:extLst>
           </p:cNvPr>
@@ -14696,10 +14696,10 @@
       </p:sp>
       <p:sp>
         <p:nvSpPr>
-          <p:cNvPr id="14" name="text-2ea0nf-13">
+          <p:cNvPr id="14" name="text-cpcnzk-13">
             <a:extLst xmlns:a="http://schemas.openxmlformats.org/drawingml/2006/main">
               <a:ext uri="{FF2B5EF4-FFF2-40B4-BE49-F238E27FC236}">
-                <a16:creationId xmlns:a16="http://schemas.microsoft.com/office/drawing/2014/main" id="{FAF6C901-401B-4D30-9262-0A99AD236A38}"/>
+                <a16:creationId xmlns:a16="http://schemas.microsoft.com/office/drawing/2014/main" id="{C69C609C-76CE-41EA-8565-AEE474CF2951}"/>
               </a:ext>
             </a:extLst>
           </p:cNvPr>
@@ -14765,7 +14765,7 @@
     </p:spTree>
     <p:extLst>
       <p:ext uri="{BB962C8B-B14F-4D97-AF65-F5344CB8AC3E}">
-        <p14:creationId xmlns:p14="http://schemas.microsoft.com/office/powerpoint/2010/main" val="1362791385"/>
+        <p14:creationId xmlns:p14="http://schemas.microsoft.com/office/powerpoint/2010/main" val="957721198"/>
       </p:ext>
     </p:extLst>
   </p:cSld>

</xml_diff>